<commit_message>
Rename notebook and update README references
</commit_message>
<xml_diff>
--- a/slides/olist_analytics.pptx
+++ b/slides/olist_analytics.pptx
@@ -4,6 +4,9 @@
   <p:sldMasterIdLst>
     <p:sldMasterId id="2147483648" r:id="rId1"/>
   </p:sldMasterIdLst>
+  <p:notesMasterIdLst>
+    <p:notesMasterId r:id="rId9"/>
+  </p:notesMasterIdLst>
   <p:sldIdLst>
     <p:sldId id="256" r:id="rId2"/>
     <p:sldId id="257" r:id="rId3"/>
@@ -13,9 +16,6 @@
     <p:sldId id="261" r:id="rId7"/>
     <p:sldId id="262" r:id="rId8"/>
   </p:sldIdLst>
-  <p:notesMasterIdLst>
-    <p:notesMasterId r:id="rId9"/>
-  </p:notesMasterIdLst>
   <p:sldSz cx="12192000" cy="6858000"/>
   <p:notesSz cx="6858000" cy="12192000"/>
   <p:defaultTextStyle>
@@ -110,13 +110,20 @@
       </a:defRPr>
     </a:lvl9pPr>
   </p:defaultTextStyle>
+  <p:extLst>
+    <p:ext uri="{EFAFB233-063F-42B5-8137-9DF3F51BA10A}">
+      <p15:sldGuideLst xmlns:p15="http://schemas.microsoft.com/office/powerpoint/2012/main"/>
+    </p:ext>
+  </p:extLst>
 </p:presentation>
 </file>
 
 <file path=ppt/charts/chart1.xml><?xml version="1.0" encoding="utf-8"?>
-<c:chartSpace xmlns:c="http://schemas.openxmlformats.org/drawingml/2006/chart" xmlns:a="http://schemas.openxmlformats.org/drawingml/2006/main" xmlns:r="http://schemas.openxmlformats.org/officeDocument/2006/relationships">
+<c:chartSpace xmlns:c="http://schemas.openxmlformats.org/drawingml/2006/chart" xmlns:a="http://schemas.openxmlformats.org/drawingml/2006/main" xmlns:r="http://schemas.openxmlformats.org/officeDocument/2006/relationships" xmlns:c16r2="http://schemas.microsoft.com/office/drawing/2015/06/chart">
   <c:date1904 val="0"/>
+  <c:lang val="en-US"/>
   <c:roundedCorners val="1"/>
+  <c:style val="2"/>
   <c:chart>
     <c:title>
       <c:tx>
@@ -139,18 +146,18 @@
                 </a:solidFill>
                 <a:latin typeface="Arial"/>
               </a:rPr>
-              <a:t>Cumulative Revenue Growth</a:t>
+              <a:t>Cumulative Revenue Growth (GH₵)</a:t>
             </a:r>
           </a:p>
         </c:rich>
       </c:tx>
-      <c:layout/>
       <c:overlay val="0"/>
     </c:title>
     <c:autoTitleDeleted val="0"/>
     <c:plotArea>
       <c:layout/>
       <c:lineChart>
+        <c:grouping val="standard"/>
         <c:varyColors val="0"/>
         <c:ser>
           <c:idx val="0"/>
@@ -167,9 +174,6 @@
             </c:strRef>
           </c:tx>
           <c:spPr>
-            <a:solidFill>
-              <a:srgbClr val="FF6B5B"/>
-            </a:solidFill>
             <a:ln w="38100" cap="flat">
               <a:solidFill>
                 <a:srgbClr val="FF6B5B"/>
@@ -179,31 +183,6 @@
             </a:ln>
             <a:effectLst/>
           </c:spPr>
-          <c:invertIfNegative val="0"/>
-          <c:dLbls>
-            <c:numFmt formatCode="#,##0" sourceLinked="0"/>
-            <c:txPr>
-              <a:bodyPr/>
-              <a:lstStyle/>
-              <a:p>
-                <a:pPr>
-                  <a:defRPr b="0" i="0" strike="noStrike" sz="1200" u="none">
-                    <a:solidFill>
-                      <a:srgbClr val="000000"/>
-                    </a:solidFill>
-                    <a:latin typeface="Arial"/>
-                  </a:defRPr>
-                </a:pPr>
-              </a:p>
-            </c:txPr>
-            <c:showLegendKey val="0"/>
-            <c:showVal val="0"/>
-            <c:showCatName val="0"/>
-            <c:showSerName val="0"/>
-            <c:showPercent val="0"/>
-            <c:showBubbleSize val="0"/>
-            <c:showLeaderLines val="0"/>
-          </c:dLbls>
           <c:marker>
             <c:symbol val="circle"/>
             <c:size val="6"/>
@@ -222,38 +201,36 @@
             </c:spPr>
           </c:marker>
           <c:cat>
-            <c:multiLvlStrRef>
+            <c:strRef>
               <c:f>Sheet1!$A$2:$A$9</c:f>
-              <c:multiLvlStrCache>
+              <c:strCache>
                 <c:ptCount val="8"/>
-                <c:lvl>
-                  <c:pt idx="0">
-                    <c:v>2016-10</c:v>
-                  </c:pt>
-                  <c:pt idx="1">
-                    <c:v>2017-01</c:v>
-                  </c:pt>
-                  <c:pt idx="2">
-                    <c:v>2017-04</c:v>
-                  </c:pt>
-                  <c:pt idx="3">
-                    <c:v>2017-07</c:v>
-                  </c:pt>
-                  <c:pt idx="4">
-                    <c:v>2017-10</c:v>
-                  </c:pt>
-                  <c:pt idx="5">
-                    <c:v>2018-01</c:v>
-                  </c:pt>
-                  <c:pt idx="6">
-                    <c:v>2018-04</c:v>
-                  </c:pt>
-                  <c:pt idx="7">
-                    <c:v>2018-07</c:v>
-                  </c:pt>
-                </c:lvl>
-              </c:multiLvlStrCache>
-            </c:multiLvlStrRef>
+                <c:pt idx="0">
+                  <c:v>2016-10</c:v>
+                </c:pt>
+                <c:pt idx="1">
+                  <c:v>2017-01</c:v>
+                </c:pt>
+                <c:pt idx="2">
+                  <c:v>2017-04</c:v>
+                </c:pt>
+                <c:pt idx="3">
+                  <c:v>2017-07</c:v>
+                </c:pt>
+                <c:pt idx="4">
+                  <c:v>2017-10</c:v>
+                </c:pt>
+                <c:pt idx="5">
+                  <c:v>2018-01</c:v>
+                </c:pt>
+                <c:pt idx="6">
+                  <c:v>2018-04</c:v>
+                </c:pt>
+                <c:pt idx="7">
+                  <c:v>2018-08</c:v>
+                </c:pt>
+              </c:strCache>
+            </c:strRef>
           </c:cat>
           <c:val>
             <c:numRef>
@@ -262,62 +239,51 @@
                 <c:formatCode>General</c:formatCode>
                 <c:ptCount val="8"/>
                 <c:pt idx="0">
-                  <c:v>10000</c:v>
+                  <c:v>108432</c:v>
                 </c:pt>
                 <c:pt idx="1">
-                  <c:v>60000</c:v>
+                  <c:v>396054</c:v>
                 </c:pt>
                 <c:pt idx="2">
-                  <c:v>700000</c:v>
+                  <c:v>2737613</c:v>
                 </c:pt>
                 <c:pt idx="3">
-                  <c:v>2100000</c:v>
+                  <c:v>6225359</c:v>
                 </c:pt>
                 <c:pt idx="4">
-                  <c:v>5200000</c:v>
+                  <c:v>12129305</c:v>
                 </c:pt>
                 <c:pt idx="5">
-                  <c:v>9000000</c:v>
+                  <c:v>20320925</c:v>
                 </c:pt>
                 <c:pt idx="6">
-                  <c:v>11800000</c:v>
+                  <c:v>24218574</c:v>
                 </c:pt>
                 <c:pt idx="7">
-                  <c:v>15700000</c:v>
+                  <c:v>33044607</c:v>
                 </c:pt>
               </c:numCache>
             </c:numRef>
           </c:val>
           <c:smooth val="1"/>
+          <c:extLst>
+            <c:ext xmlns:c16="http://schemas.microsoft.com/office/drawing/2014/chart" uri="{C3380CC4-5D6E-409C-BE32-E72D297353CC}">
+              <c16:uniqueId val="{00000000-AD35-489B-8392-88ED0643F118}"/>
+            </c:ext>
+          </c:extLst>
         </c:ser>
         <c:dLbls>
-          <c:numFmt formatCode="#,##0" sourceLinked="0"/>
-          <c:txPr>
-            <a:bodyPr/>
-            <a:lstStyle/>
-            <a:p>
-              <a:pPr>
-                <a:defRPr b="0" i="0" strike="noStrike" sz="1200" u="none">
-                  <a:solidFill>
-                    <a:srgbClr val="000000"/>
-                  </a:solidFill>
-                  <a:latin typeface="Arial"/>
-                </a:defRPr>
-              </a:pPr>
-            </a:p>
-          </c:txPr>
           <c:showLegendKey val="0"/>
           <c:showVal val="0"/>
           <c:showCatName val="0"/>
           <c:showSerName val="0"/>
           <c:showPercent val="0"/>
           <c:showBubbleSize val="0"/>
-          <c:showLeaderLines val="0"/>
         </c:dLbls>
         <c:marker val="1"/>
+        <c:smooth val="0"/>
         <c:axId val="2094734554"/>
         <c:axId val="2094734552"/>
-        <c:axId val="2094734556"/>
       </c:lineChart>
       <c:catAx>
         <c:axId val="2094734554"/>
@@ -358,6 +324,7 @@
         <c:crosses val="autoZero"/>
         <c:auto val="1"/>
         <c:lblAlgn val="ctr"/>
+        <c:lblOffset val="100"/>
         <c:noMultiLvlLbl val="1"/>
       </c:catAx>
       <c:valAx>
@@ -420,6 +387,7 @@
     </c:plotArea>
     <c:plotVisOnly val="1"/>
     <c:dispBlanksAs val="span"/>
+    <c:showDLblsOverMax val="1"/>
   </c:chart>
   <c:spPr>
     <a:solidFill>
@@ -437,9 +405,11 @@
 </file>
 
 <file path=ppt/charts/chart2.xml><?xml version="1.0" encoding="utf-8"?>
-<c:chartSpace xmlns:c="http://schemas.openxmlformats.org/drawingml/2006/chart" xmlns:a="http://schemas.openxmlformats.org/drawingml/2006/main" xmlns:r="http://schemas.openxmlformats.org/officeDocument/2006/relationships">
+<c:chartSpace xmlns:c="http://schemas.openxmlformats.org/drawingml/2006/chart" xmlns:a="http://schemas.openxmlformats.org/drawingml/2006/main" xmlns:r="http://schemas.openxmlformats.org/officeDocument/2006/relationships" xmlns:c16r2="http://schemas.microsoft.com/office/drawing/2015/06/chart">
   <c:date1904 val="0"/>
+  <c:lang val="en-US"/>
   <c:roundedCorners val="1"/>
+  <c:style val="2"/>
   <c:chart>
     <c:title>
       <c:tx>
@@ -467,7 +437,6 @@
           </a:p>
         </c:rich>
       </c:tx>
-      <c:layout/>
       <c:overlay val="0"/>
     </c:title>
     <c:autoTitleDeleted val="0"/>
@@ -500,18 +469,26 @@
           <c:invertIfNegative val="0"/>
           <c:dLbls>
             <c:numFmt formatCode="#,##0" sourceLinked="0"/>
+            <c:spPr>
+              <a:noFill/>
+              <a:ln>
+                <a:noFill/>
+              </a:ln>
+              <a:effectLst/>
+            </c:spPr>
             <c:txPr>
               <a:bodyPr/>
               <a:lstStyle/>
               <a:p>
                 <a:pPr>
-                  <a:defRPr b="0" i="0" strike="noStrike" sz="1100" u="none">
+                  <a:defRPr sz="1100" b="0" i="0" u="none" strike="noStrike">
                     <a:solidFill>
                       <a:srgbClr val="FFFFFF"/>
                     </a:solidFill>
                     <a:latin typeface="Arial"/>
                   </a:defRPr>
                 </a:pPr>
+                <a:endParaRPr lang="en-US"/>
               </a:p>
             </c:txPr>
             <c:showLegendKey val="0"/>
@@ -521,28 +498,31 @@
             <c:showPercent val="0"/>
             <c:showBubbleSize val="0"/>
             <c:showLeaderLines val="0"/>
+            <c:extLst>
+              <c:ext xmlns:c15="http://schemas.microsoft.com/office/drawing/2012/chart" uri="{CE6537A1-D6FC-4f65-9D91-7224C49458BB}">
+                <c15:showLeaderLines val="0"/>
+              </c:ext>
+            </c:extLst>
           </c:dLbls>
           <c:cat>
-            <c:multiLvlStrRef>
+            <c:strRef>
               <c:f>Sheet1!$A$2:$A$5</c:f>
-              <c:multiLvlStrCache>
+              <c:strCache>
                 <c:ptCount val="4"/>
-                <c:lvl>
-                  <c:pt idx="0">
-                    <c:v>Q1 — Top</c:v>
-                  </c:pt>
-                  <c:pt idx="1">
-                    <c:v>Q2</c:v>
-                  </c:pt>
-                  <c:pt idx="2">
-                    <c:v>Q3</c:v>
-                  </c:pt>
-                  <c:pt idx="3">
-                    <c:v>Q4 — Bottom</c:v>
-                  </c:pt>
-                </c:lvl>
-              </c:multiLvlStrCache>
-            </c:multiLvlStrRef>
+                <c:pt idx="0">
+                  <c:v>Q1 — Top</c:v>
+                </c:pt>
+                <c:pt idx="1">
+                  <c:v>Q2</c:v>
+                </c:pt>
+                <c:pt idx="2">
+                  <c:v>Q3</c:v>
+                </c:pt>
+                <c:pt idx="3">
+                  <c:v>Q4 — Bottom</c:v>
+                </c:pt>
+              </c:strCache>
+            </c:strRef>
           </c:cat>
           <c:val>
             <c:numRef>
@@ -551,50 +531,37 @@
                 <c:formatCode>General</c:formatCode>
                 <c:ptCount val="4"/>
                 <c:pt idx="0">
-                  <c:v>396</c:v>
+                  <c:v>828</c:v>
                 </c:pt>
                 <c:pt idx="1">
-                  <c:v>141</c:v>
+                  <c:v>297</c:v>
                 </c:pt>
                 <c:pt idx="2">
-                  <c:v>84</c:v>
+                  <c:v>176</c:v>
                 </c:pt>
                 <c:pt idx="3">
-                  <c:v>47</c:v>
+                  <c:v>92</c:v>
                 </c:pt>
               </c:numCache>
             </c:numRef>
           </c:val>
+          <c:extLst>
+            <c:ext xmlns:c16="http://schemas.microsoft.com/office/drawing/2014/chart" uri="{C3380CC4-5D6E-409C-BE32-E72D297353CC}">
+              <c16:uniqueId val="{00000000-5400-4801-86C4-E3FC02442747}"/>
+            </c:ext>
+          </c:extLst>
         </c:ser>
         <c:dLbls>
-          <c:numFmt formatCode="#,##0" sourceLinked="0"/>
-          <c:txPr>
-            <a:bodyPr/>
-            <a:lstStyle/>
-            <a:p>
-              <a:pPr>
-                <a:defRPr b="0" i="0" strike="noStrike" sz="1100" u="none">
-                  <a:solidFill>
-                    <a:srgbClr val="FFFFFF"/>
-                  </a:solidFill>
-                  <a:latin typeface="Arial"/>
-                </a:defRPr>
-              </a:pPr>
-            </a:p>
-          </c:txPr>
           <c:showLegendKey val="0"/>
           <c:showVal val="1"/>
           <c:showCatName val="0"/>
           <c:showSerName val="0"/>
           <c:showPercent val="0"/>
           <c:showBubbleSize val="0"/>
-          <c:showLeaderLines val="0"/>
         </c:dLbls>
         <c:gapWidth val="150"/>
-        <c:overlap val="0"/>
         <c:axId val="2094734554"/>
         <c:axId val="2094734552"/>
-        <c:axId val="2094734556"/>
       </c:barChart>
       <c:catAx>
         <c:axId val="2094734554"/>
@@ -635,6 +602,7 @@
         <c:crosses val="autoZero"/>
         <c:auto val="1"/>
         <c:lblAlgn val="ctr"/>
+        <c:lblOffset val="100"/>
         <c:noMultiLvlLbl val="1"/>
       </c:catAx>
       <c:valAx>
@@ -697,6 +665,7 @@
     </c:plotArea>
     <c:plotVisOnly val="1"/>
     <c:dispBlanksAs val="span"/>
+    <c:showDLblsOverMax val="1"/>
   </c:chart>
   <c:spPr>
     <a:solidFill>
@@ -714,9 +683,11 @@
 </file>
 
 <file path=ppt/charts/chart3.xml><?xml version="1.0" encoding="utf-8"?>
-<c:chartSpace xmlns:c="http://schemas.openxmlformats.org/drawingml/2006/chart" xmlns:a="http://schemas.openxmlformats.org/drawingml/2006/main" xmlns:r="http://schemas.openxmlformats.org/officeDocument/2006/relationships">
+<c:chartSpace xmlns:c="http://schemas.openxmlformats.org/drawingml/2006/chart" xmlns:a="http://schemas.openxmlformats.org/drawingml/2006/main" xmlns:r="http://schemas.openxmlformats.org/officeDocument/2006/relationships" xmlns:c16r2="http://schemas.microsoft.com/office/drawing/2015/06/chart">
   <c:date1904 val="0"/>
+  <c:lang val="en-US"/>
   <c:roundedCorners val="1"/>
+  <c:style val="2"/>
   <c:chart>
     <c:title>
       <c:tx>
@@ -739,12 +710,11 @@
                 </a:solidFill>
                 <a:latin typeface="Arial"/>
               </a:rPr>
-              <a:t>Raw Accuracy (misleading on its own)</a:t>
+              <a:t>Raw Accuracy (misleading alone)</a:t>
             </a:r>
           </a:p>
         </c:rich>
       </c:tx>
-      <c:layout/>
       <c:overlay val="0"/>
     </c:title>
     <c:autoTitleDeleted val="0"/>
@@ -775,40 +745,15 @@
             <a:effectLst/>
           </c:spPr>
           <c:invertIfNegative val="0"/>
-          <c:dLbls>
-            <c:numFmt formatCode="#,##0" sourceLinked="0"/>
-            <c:txPr>
-              <a:bodyPr/>
-              <a:lstStyle/>
-              <a:p>
-                <a:pPr>
-                  <a:defRPr b="0" i="0" strike="noStrike" sz="1100" u="none">
-                    <a:solidFill>
-                      <a:srgbClr val="0B2545"/>
-                    </a:solidFill>
-                    <a:latin typeface="Arial"/>
-                  </a:defRPr>
-                </a:pPr>
-              </a:p>
-            </c:txPr>
-            <c:showLegendKey val="0"/>
-            <c:showVal val="1"/>
-            <c:showCatName val="0"/>
-            <c:showSerName val="0"/>
-            <c:showPercent val="0"/>
-            <c:showBubbleSize val="0"/>
-            <c:showLeaderLines val="0"/>
-          </c:dLbls>
           <c:dPt>
             <c:idx val="0"/>
             <c:invertIfNegative val="0"/>
             <c:bubble3D val="0"/>
-            <c:spPr>
-              <a:solidFill>
-                <a:srgbClr val="5C7080"/>
-              </a:solidFill>
-              <a:effectLst/>
-            </c:spPr>
+            <c:extLst>
+              <c:ext xmlns:c16="http://schemas.microsoft.com/office/drawing/2014/chart" uri="{C3380CC4-5D6E-409C-BE32-E72D297353CC}">
+                <c16:uniqueId val="{00000001-600B-43A7-9BB4-4A104B263804}"/>
+              </c:ext>
+            </c:extLst>
           </c:dPt>
           <c:dPt>
             <c:idx val="1"/>
@@ -820,24 +765,64 @@
               </a:solidFill>
               <a:effectLst/>
             </c:spPr>
+            <c:extLst>
+              <c:ext xmlns:c16="http://schemas.microsoft.com/office/drawing/2014/chart" uri="{C3380CC4-5D6E-409C-BE32-E72D297353CC}">
+                <c16:uniqueId val="{00000003-600B-43A7-9BB4-4A104B263804}"/>
+              </c:ext>
+            </c:extLst>
           </c:dPt>
+          <c:dLbls>
+            <c:numFmt formatCode="#,##0" sourceLinked="0"/>
+            <c:spPr>
+              <a:noFill/>
+              <a:ln>
+                <a:noFill/>
+              </a:ln>
+              <a:effectLst/>
+            </c:spPr>
+            <c:txPr>
+              <a:bodyPr/>
+              <a:lstStyle/>
+              <a:p>
+                <a:pPr>
+                  <a:defRPr sz="1100" b="0" i="0" u="none" strike="noStrike">
+                    <a:solidFill>
+                      <a:srgbClr val="0B2545"/>
+                    </a:solidFill>
+                    <a:latin typeface="Arial"/>
+                  </a:defRPr>
+                </a:pPr>
+                <a:endParaRPr lang="en-US"/>
+              </a:p>
+            </c:txPr>
+            <c:showLegendKey val="0"/>
+            <c:showVal val="1"/>
+            <c:showCatName val="0"/>
+            <c:showSerName val="0"/>
+            <c:showPercent val="0"/>
+            <c:showBubbleSize val="0"/>
+            <c:showLeaderLines val="0"/>
+            <c:extLst>
+              <c:ext xmlns:c15="http://schemas.microsoft.com/office/drawing/2012/chart" uri="{CE6537A1-D6FC-4f65-9D91-7224C49458BB}">
+                <c15:showLeaderLines val="0"/>
+              </c:ext>
+            </c:extLst>
+          </c:dLbls>
           <c:cat>
-            <c:multiLvlStrRef>
+            <c:strRef>
               <c:f>Sheet1!$A$2:$A$3</c:f>
-              <c:multiLvlStrCache>
+              <c:strCache>
                 <c:ptCount val="2"/>
-                <c:lvl>
-                  <c:pt idx="0">
-                    <c:v>Baseline
+                <c:pt idx="0">
+                  <c:v>Baseline
 (always “on-time”)</c:v>
-                  </c:pt>
-                  <c:pt idx="1">
-                    <c:v>Logistic
+                </c:pt>
+                <c:pt idx="1">
+                  <c:v>Logistic
 Regression</c:v>
-                  </c:pt>
-                </c:lvl>
-              </c:multiLvlStrCache>
-            </c:multiLvlStrRef>
+                </c:pt>
+              </c:strCache>
+            </c:strRef>
           </c:cat>
           <c:val>
             <c:numRef>
@@ -846,44 +831,31 @@
                 <c:formatCode>General</c:formatCode>
                 <c:ptCount val="2"/>
                 <c:pt idx="0">
-                  <c:v>0.921</c:v>
+                  <c:v>0.92100000000000004</c:v>
                 </c:pt>
                 <c:pt idx="1">
-                  <c:v>0.687</c:v>
+                  <c:v>0.68700000000000006</c:v>
                 </c:pt>
               </c:numCache>
             </c:numRef>
           </c:val>
+          <c:extLst>
+            <c:ext xmlns:c16="http://schemas.microsoft.com/office/drawing/2014/chart" uri="{C3380CC4-5D6E-409C-BE32-E72D297353CC}">
+              <c16:uniqueId val="{00000004-600B-43A7-9BB4-4A104B263804}"/>
+            </c:ext>
+          </c:extLst>
         </c:ser>
         <c:dLbls>
-          <c:numFmt formatCode="#,##0" sourceLinked="0"/>
-          <c:txPr>
-            <a:bodyPr/>
-            <a:lstStyle/>
-            <a:p>
-              <a:pPr>
-                <a:defRPr b="0" i="0" strike="noStrike" sz="1100" u="none">
-                  <a:solidFill>
-                    <a:srgbClr val="0B2545"/>
-                  </a:solidFill>
-                  <a:latin typeface="Arial"/>
-                </a:defRPr>
-              </a:pPr>
-            </a:p>
-          </c:txPr>
           <c:showLegendKey val="0"/>
           <c:showVal val="1"/>
           <c:showCatName val="0"/>
           <c:showSerName val="0"/>
           <c:showPercent val="0"/>
           <c:showBubbleSize val="0"/>
-          <c:showLeaderLines val="0"/>
         </c:dLbls>
         <c:gapWidth val="150"/>
-        <c:overlap val="0"/>
         <c:axId val="2094734554"/>
         <c:axId val="2094734552"/>
-        <c:axId val="2094734556"/>
       </c:barChart>
       <c:catAx>
         <c:axId val="2094734554"/>
@@ -924,6 +896,7 @@
         <c:crosses val="autoZero"/>
         <c:auto val="1"/>
         <c:lblAlgn val="ctr"/>
+        <c:lblOffset val="100"/>
         <c:noMultiLvlLbl val="1"/>
       </c:catAx>
       <c:valAx>
@@ -986,6 +959,7 @@
     </c:plotArea>
     <c:plotVisOnly val="1"/>
     <c:dispBlanksAs val="span"/>
+    <c:showDLblsOverMax val="1"/>
   </c:chart>
   <c:spPr>
     <a:solidFill>
@@ -1003,9 +977,11 @@
 </file>
 
 <file path=ppt/charts/chart4.xml><?xml version="1.0" encoding="utf-8"?>
-<c:chartSpace xmlns:c="http://schemas.openxmlformats.org/drawingml/2006/chart" xmlns:a="http://schemas.openxmlformats.org/drawingml/2006/main" xmlns:r="http://schemas.openxmlformats.org/officeDocument/2006/relationships">
+<c:chartSpace xmlns:c="http://schemas.openxmlformats.org/drawingml/2006/chart" xmlns:a="http://schemas.openxmlformats.org/drawingml/2006/main" xmlns:r="http://schemas.openxmlformats.org/officeDocument/2006/relationships" xmlns:c16r2="http://schemas.microsoft.com/office/drawing/2015/06/chart">
   <c:date1904 val="0"/>
+  <c:lang val="en-US"/>
   <c:roundedCorners val="1"/>
+  <c:style val="2"/>
   <c:chart>
     <c:title>
       <c:tx>
@@ -1033,7 +1009,6 @@
           </a:p>
         </c:rich>
       </c:tx>
-      <c:layout/>
       <c:overlay val="0"/>
     </c:title>
     <c:autoTitleDeleted val="0"/>
@@ -1064,40 +1039,15 @@
             <a:effectLst/>
           </c:spPr>
           <c:invertIfNegative val="0"/>
-          <c:dLbls>
-            <c:numFmt formatCode="#,##0" sourceLinked="0"/>
-            <c:txPr>
-              <a:bodyPr/>
-              <a:lstStyle/>
-              <a:p>
-                <a:pPr>
-                  <a:defRPr b="0" i="0" strike="noStrike" sz="1100" u="none">
-                    <a:solidFill>
-                      <a:srgbClr val="0B2545"/>
-                    </a:solidFill>
-                    <a:latin typeface="Arial"/>
-                  </a:defRPr>
-                </a:pPr>
-              </a:p>
-            </c:txPr>
-            <c:showLegendKey val="0"/>
-            <c:showVal val="1"/>
-            <c:showCatName val="0"/>
-            <c:showSerName val="0"/>
-            <c:showPercent val="0"/>
-            <c:showBubbleSize val="0"/>
-            <c:showLeaderLines val="0"/>
-          </c:dLbls>
           <c:dPt>
             <c:idx val="0"/>
             <c:invertIfNegative val="0"/>
             <c:bubble3D val="0"/>
-            <c:spPr>
-              <a:solidFill>
-                <a:srgbClr val="5C7080"/>
-              </a:solidFill>
-              <a:effectLst/>
-            </c:spPr>
+            <c:extLst>
+              <c:ext xmlns:c16="http://schemas.microsoft.com/office/drawing/2014/chart" uri="{C3380CC4-5D6E-409C-BE32-E72D297353CC}">
+                <c16:uniqueId val="{00000001-3C93-44B1-B0CC-ECE13CB05D37}"/>
+              </c:ext>
+            </c:extLst>
           </c:dPt>
           <c:dPt>
             <c:idx val="1"/>
@@ -1109,23 +1059,63 @@
               </a:solidFill>
               <a:effectLst/>
             </c:spPr>
+            <c:extLst>
+              <c:ext xmlns:c16="http://schemas.microsoft.com/office/drawing/2014/chart" uri="{C3380CC4-5D6E-409C-BE32-E72D297353CC}">
+                <c16:uniqueId val="{00000003-3C93-44B1-B0CC-ECE13CB05D37}"/>
+              </c:ext>
+            </c:extLst>
           </c:dPt>
+          <c:dLbls>
+            <c:numFmt formatCode="#,##0" sourceLinked="0"/>
+            <c:spPr>
+              <a:noFill/>
+              <a:ln>
+                <a:noFill/>
+              </a:ln>
+              <a:effectLst/>
+            </c:spPr>
+            <c:txPr>
+              <a:bodyPr/>
+              <a:lstStyle/>
+              <a:p>
+                <a:pPr>
+                  <a:defRPr sz="1100" b="0" i="0" u="none" strike="noStrike">
+                    <a:solidFill>
+                      <a:srgbClr val="0B2545"/>
+                    </a:solidFill>
+                    <a:latin typeface="Arial"/>
+                  </a:defRPr>
+                </a:pPr>
+                <a:endParaRPr lang="en-US"/>
+              </a:p>
+            </c:txPr>
+            <c:showLegendKey val="0"/>
+            <c:showVal val="1"/>
+            <c:showCatName val="0"/>
+            <c:showSerName val="0"/>
+            <c:showPercent val="0"/>
+            <c:showBubbleSize val="0"/>
+            <c:showLeaderLines val="0"/>
+            <c:extLst>
+              <c:ext xmlns:c15="http://schemas.microsoft.com/office/drawing/2012/chart" uri="{CE6537A1-D6FC-4f65-9D91-7224C49458BB}">
+                <c15:showLeaderLines val="0"/>
+              </c:ext>
+            </c:extLst>
+          </c:dLbls>
           <c:cat>
-            <c:multiLvlStrRef>
+            <c:strRef>
               <c:f>Sheet1!$A$2:$A$3</c:f>
-              <c:multiLvlStrCache>
+              <c:strCache>
                 <c:ptCount val="2"/>
-                <c:lvl>
-                  <c:pt idx="0">
-                    <c:v>Baseline</c:v>
-                  </c:pt>
-                  <c:pt idx="1">
-                    <c:v>Logistic
+                <c:pt idx="0">
+                  <c:v>Baseline</c:v>
+                </c:pt>
+                <c:pt idx="1">
+                  <c:v>Logistic
 Regression</c:v>
-                  </c:pt>
-                </c:lvl>
-              </c:multiLvlStrCache>
-            </c:multiLvlStrRef>
+                </c:pt>
+              </c:strCache>
+            </c:strRef>
           </c:cat>
           <c:val>
             <c:numRef>
@@ -1142,36 +1132,23 @@
               </c:numCache>
             </c:numRef>
           </c:val>
+          <c:extLst>
+            <c:ext xmlns:c16="http://schemas.microsoft.com/office/drawing/2014/chart" uri="{C3380CC4-5D6E-409C-BE32-E72D297353CC}">
+              <c16:uniqueId val="{00000004-3C93-44B1-B0CC-ECE13CB05D37}"/>
+            </c:ext>
+          </c:extLst>
         </c:ser>
         <c:dLbls>
-          <c:numFmt formatCode="#,##0" sourceLinked="0"/>
-          <c:txPr>
-            <a:bodyPr/>
-            <a:lstStyle/>
-            <a:p>
-              <a:pPr>
-                <a:defRPr b="0" i="0" strike="noStrike" sz="1100" u="none">
-                  <a:solidFill>
-                    <a:srgbClr val="0B2545"/>
-                  </a:solidFill>
-                  <a:latin typeface="Arial"/>
-                </a:defRPr>
-              </a:pPr>
-            </a:p>
-          </c:txPr>
           <c:showLegendKey val="0"/>
           <c:showVal val="1"/>
           <c:showCatName val="0"/>
           <c:showSerName val="0"/>
           <c:showPercent val="0"/>
           <c:showBubbleSize val="0"/>
-          <c:showLeaderLines val="0"/>
         </c:dLbls>
         <c:gapWidth val="150"/>
-        <c:overlap val="0"/>
         <c:axId val="2094734554"/>
         <c:axId val="2094734552"/>
-        <c:axId val="2094734556"/>
       </c:barChart>
       <c:catAx>
         <c:axId val="2094734554"/>
@@ -1212,6 +1189,7 @@
         <c:crosses val="autoZero"/>
         <c:auto val="1"/>
         <c:lblAlgn val="ctr"/>
+        <c:lblOffset val="100"/>
         <c:noMultiLvlLbl val="1"/>
       </c:catAx>
       <c:valAx>
@@ -1274,6 +1252,7 @@
     </c:plotArea>
     <c:plotVisOnly val="1"/>
     <c:dispBlanksAs val="span"/>
+    <c:showDLblsOverMax val="1"/>
   </c:chart>
   <c:spPr>
     <a:solidFill>
@@ -1312,234 +1291,10 @@
           <a:chExt cx="0" cy="0"/>
         </a:xfrm>
       </p:grpSpPr>
-      <p:sp>
-        <p:nvSpPr>
-          <p:cNvPr id="2" name="Header Placeholder 1"/>
-          <p:cNvSpPr>
-            <a:spLocks noGrp="1"/>
-          </p:cNvSpPr>
-          <p:nvPr>
-            <p:ph type="hdr" sz="quarter"/>
-          </p:nvPr>
-        </p:nvSpPr>
-        <p:spPr>
-          <a:xfrm>
-            <a:off x="0" y="0"/>
-            <a:ext cx="2971800" cy="458788"/>
-          </a:xfrm>
-          <a:prstGeom prst="rect">
-            <a:avLst/>
-          </a:prstGeom>
-        </p:spPr>
-        <p:txBody>
-          <a:bodyPr vert="horz" lIns="91440" tIns="45720" rIns="91440" bIns="45720" rtlCol="0"/>
-          <a:lstStyle>
-            <a:lvl1pPr algn="l">
-              <a:defRPr sz="1200"/>
-            </a:lvl1pPr>
-          </a:lstStyle>
-          <a:p>
-            <a:endParaRPr lang="en-US"/>
-          </a:p>
-        </p:txBody>
-      </p:sp>
-      <p:sp>
-        <p:nvSpPr>
-          <p:cNvPr id="3" name="Date Placeholder 2"/>
-          <p:cNvSpPr>
-            <a:spLocks noGrp="1"/>
-          </p:cNvSpPr>
-          <p:nvPr>
-            <p:ph type="dt" idx="1"/>
-          </p:nvPr>
-        </p:nvSpPr>
-        <p:spPr>
-          <a:xfrm>
-            <a:off x="3884613" y="0"/>
-            <a:ext cx="2971800" cy="458788"/>
-          </a:xfrm>
-          <a:prstGeom prst="rect">
-            <a:avLst/>
-          </a:prstGeom>
-        </p:spPr>
-        <p:txBody>
-          <a:bodyPr vert="horz" lIns="91440" tIns="45720" rIns="91440" bIns="45720" rtlCol="0"/>
-          <a:lstStyle>
-            <a:lvl1pPr algn="r">
-              <a:defRPr sz="1200"/>
-            </a:lvl1pPr>
-          </a:lstStyle>
-          <a:p>
-            <a:fld id="{5282F153-3F37-0F45-9E97-73ACFA13230C}" type="datetimeFigureOut">
-              <a:rPr lang="en-US"/>
-              <a:t>7/23/19</a:t>
-            </a:fld>
-            <a:endParaRPr lang="en-US"/>
-          </a:p>
-        </p:txBody>
-      </p:sp>
-      <p:sp>
-        <p:nvSpPr>
-          <p:cNvPr id="4" name="Slide Image Placeholder 3"/>
-          <p:cNvSpPr>
-            <a:spLocks noGrp="1" noRot="1" noChangeAspect="1"/>
-          </p:cNvSpPr>
-          <p:nvPr>
-            <p:ph type="sldImg" idx="2"/>
-          </p:nvPr>
-        </p:nvSpPr>
-        <p:spPr>
-          <a:xfrm>
-            <a:off x="685800" y="1143000"/>
-            <a:ext cx="5486400" cy="3086100"/>
-          </a:xfrm>
-          <a:prstGeom prst="rect">
-            <a:avLst/>
-          </a:prstGeom>
-          <a:noFill/>
-          <a:ln w="12700">
-            <a:solidFill>
-              <a:prstClr val="black"/>
-            </a:solidFill>
-          </a:ln>
-        </p:spPr>
-        <p:txBody>
-          <a:bodyPr vert="horz" lIns="91440" tIns="45720" rIns="91440" bIns="45720" rtlCol="0" anchor="ctr"/>
-          <a:lstStyle/>
-          <a:p>
-            <a:endParaRPr lang="en-US"/>
-          </a:p>
-        </p:txBody>
-      </p:sp>
-      <p:sp>
-        <p:nvSpPr>
-          <p:cNvPr id="5" name="Notes Placeholder 4"/>
-          <p:cNvSpPr>
-            <a:spLocks noGrp="1"/>
-          </p:cNvSpPr>
-          <p:nvPr>
-            <p:ph type="body" sz="quarter" idx="3"/>
-          </p:nvPr>
-        </p:nvSpPr>
-        <p:spPr>
-          <a:xfrm>
-            <a:off x="685800" y="4400550"/>
-            <a:ext cx="5486400" cy="3600450"/>
-          </a:xfrm>
-          <a:prstGeom prst="rect">
-            <a:avLst/>
-          </a:prstGeom>
-        </p:spPr>
-        <p:txBody>
-          <a:bodyPr vert="horz" lIns="91440" tIns="45720" rIns="91440" bIns="45720" rtlCol="0"/>
-          <a:lstStyle/>
-          <a:p>
-            <a:pPr lvl="0"/>
-            <a:r>
-              <a:rPr lang="en-US"/>
-              <a:t>Click to edit Master text styles</a:t>
-            </a:r>
-          </a:p>
-          <a:p>
-            <a:pPr lvl="1"/>
-            <a:r>
-              <a:rPr lang="en-US"/>
-              <a:t>Second level</a:t>
-            </a:r>
-          </a:p>
-          <a:p>
-            <a:pPr lvl="2"/>
-            <a:r>
-              <a:rPr lang="en-US"/>
-              <a:t>Third level</a:t>
-            </a:r>
-          </a:p>
-          <a:p>
-            <a:pPr lvl="3"/>
-            <a:r>
-              <a:rPr lang="en-US"/>
-              <a:t>Fourth level</a:t>
-            </a:r>
-          </a:p>
-          <a:p>
-            <a:pPr lvl="4"/>
-            <a:r>
-              <a:rPr lang="en-US"/>
-              <a:t>Fifth level</a:t>
-            </a:r>
-          </a:p>
-        </p:txBody>
-      </p:sp>
-      <p:sp>
-        <p:nvSpPr>
-          <p:cNvPr id="6" name="Footer Placeholder 5"/>
-          <p:cNvSpPr>
-            <a:spLocks noGrp="1"/>
-          </p:cNvSpPr>
-          <p:nvPr>
-            <p:ph type="ftr" sz="quarter" idx="4"/>
-          </p:nvPr>
-        </p:nvSpPr>
-        <p:spPr>
-          <a:xfrm>
-            <a:off x="0" y="8685213"/>
-            <a:ext cx="2971800" cy="458787"/>
-          </a:xfrm>
-          <a:prstGeom prst="rect">
-            <a:avLst/>
-          </a:prstGeom>
-        </p:spPr>
-        <p:txBody>
-          <a:bodyPr vert="horz" lIns="91440" tIns="45720" rIns="91440" bIns="45720" rtlCol="0" anchor="b"/>
-          <a:lstStyle>
-            <a:lvl1pPr algn="l">
-              <a:defRPr sz="1200"/>
-            </a:lvl1pPr>
-          </a:lstStyle>
-          <a:p>
-            <a:endParaRPr lang="en-US"/>
-          </a:p>
-        </p:txBody>
-      </p:sp>
-      <p:sp>
-        <p:nvSpPr>
-          <p:cNvPr id="7" name="Slide Number Placeholder 6"/>
-          <p:cNvSpPr>
-            <a:spLocks noGrp="1"/>
-          </p:cNvSpPr>
-          <p:nvPr>
-            <p:ph type="sldNum" sz="quarter" idx="5"/>
-          </p:nvPr>
-        </p:nvSpPr>
-        <p:spPr>
-          <a:xfrm>
-            <a:off x="3884613" y="8685213"/>
-            <a:ext cx="2971800" cy="458787"/>
-          </a:xfrm>
-          <a:prstGeom prst="rect">
-            <a:avLst/>
-          </a:prstGeom>
-        </p:spPr>
-        <p:txBody>
-          <a:bodyPr vert="horz" lIns="91440" tIns="45720" rIns="91440" bIns="45720" rtlCol="0" anchor="b"/>
-          <a:lstStyle>
-            <a:lvl1pPr algn="r">
-              <a:defRPr sz="1200"/>
-            </a:lvl1pPr>
-          </a:lstStyle>
-          <a:p>
-            <a:fld id="{CE5E9CC1-C706-0F49-92D6-E571CC5EEA8F}" type="slidenum">
-              <a:rPr lang="en-US"/>
-              <a:t>‹#›</a:t>
-            </a:fld>
-            <a:endParaRPr lang="en-US"/>
-          </a:p>
-        </p:txBody>
-      </p:sp>
     </p:spTree>
     <p:extLst>
       <p:ext uri="{BB962C8B-B14F-4D97-AF65-F5344CB8AC3E}">
-        <p14:creationId xmlns:p14="http://schemas.microsoft.com/office/powerpoint/2010/main" val="1024086991"/>
+        <p14:creationId xmlns:p14="http://schemas.microsoft.com/office/powerpoint/2010/main" val="3586011183"/>
       </p:ext>
     </p:extLst>
   </p:cSld>
@@ -1683,10 +1438,6 @@
           <a:bodyPr/>
           <a:lstStyle/>
           <a:p>
-            <a:r>
-              <a:rPr lang="en-US" dirty="0"/>
-              <a:t/>
-            </a:r>
             <a:endParaRPr lang="en-US" dirty="0"/>
           </a:p>
         </p:txBody>
@@ -1771,10 +1522,6 @@
           <a:bodyPr/>
           <a:lstStyle/>
           <a:p>
-            <a:r>
-              <a:rPr lang="en-US" dirty="0"/>
-              <a:t/>
-            </a:r>
             <a:endParaRPr lang="en-US" dirty="0"/>
           </a:p>
         </p:txBody>
@@ -1859,10 +1606,6 @@
           <a:bodyPr/>
           <a:lstStyle/>
           <a:p>
-            <a:r>
-              <a:rPr lang="en-US" dirty="0"/>
-              <a:t/>
-            </a:r>
             <a:endParaRPr lang="en-US" dirty="0"/>
           </a:p>
         </p:txBody>
@@ -1947,10 +1690,6 @@
           <a:bodyPr/>
           <a:lstStyle/>
           <a:p>
-            <a:r>
-              <a:rPr lang="en-US" dirty="0"/>
-              <a:t/>
-            </a:r>
             <a:endParaRPr lang="en-US" dirty="0"/>
           </a:p>
         </p:txBody>
@@ -2035,10 +1774,6 @@
           <a:bodyPr/>
           <a:lstStyle/>
           <a:p>
-            <a:r>
-              <a:rPr lang="en-US" dirty="0"/>
-              <a:t/>
-            </a:r>
             <a:endParaRPr lang="en-US" dirty="0"/>
           </a:p>
         </p:txBody>
@@ -2123,10 +1858,6 @@
           <a:bodyPr/>
           <a:lstStyle/>
           <a:p>
-            <a:r>
-              <a:rPr lang="en-US" dirty="0"/>
-              <a:t/>
-            </a:r>
             <a:endParaRPr lang="en-US" dirty="0"/>
           </a:p>
         </p:txBody>
@@ -2211,10 +1942,6 @@
           <a:bodyPr/>
           <a:lstStyle/>
           <a:p>
-            <a:r>
-              <a:rPr lang="en-US" dirty="0"/>
-              <a:t/>
-            </a:r>
             <a:endParaRPr lang="en-US" dirty="0"/>
           </a:p>
         </p:txBody>
@@ -2288,6 +2015,11 @@
 <file path=ppt/slideMasters/slideMaster1.xml><?xml version="1.0" encoding="utf-8"?>
 <p:sldMaster xmlns:a="http://schemas.openxmlformats.org/drawingml/2006/main" xmlns:r="http://schemas.openxmlformats.org/officeDocument/2006/relationships" xmlns:p="http://schemas.openxmlformats.org/presentationml/2006/main">
   <p:cSld>
+    <p:bg>
+      <p:bgRef idx="1001">
+        <a:schemeClr val="bg1"/>
+      </p:bgRef>
+    </p:bg>
     <p:spTree>
       <p:nvGrpSpPr>
         <p:cNvPr id="1" name=""/>
@@ -2570,6 +2302,7 @@
         <a:solidFill>
           <a:srgbClr val="0B2545"/>
         </a:solidFill>
+        <a:effectLst/>
       </p:bgPr>
     </p:bg>
     <p:spTree>
@@ -2588,14 +2321,14 @@
       </p:grpSpPr>
       <p:pic>
         <p:nvPicPr>
-          <p:cNvPr id="2" name="Image 0" descr="preencoded.png">    </p:cNvPr>
+          <p:cNvPr id="2" name="Image 0" descr="preencoded.png"/>
           <p:cNvPicPr>
             <a:picLocks noChangeAspect="1"/>
           </p:cNvPicPr>
           <p:nvPr/>
         </p:nvPicPr>
         <p:blipFill>
-          <a:blip r:embed="rId1">
+          <a:blip r:embed="rId3">
             <a:alphaModFix amt="85000"/>
           </a:blip>
           <a:stretch>
@@ -2633,11 +2366,11 @@
           <a:bodyPr wrap="square" lIns="0" tIns="0" rIns="0" bIns="0" rtlCol="0" anchor="ctr"/>
           <a:lstStyle/>
           <a:p>
-            <a:pPr indent="0" marL="0">
+            <a:pPr marL="0" indent="0">
               <a:buNone/>
             </a:pPr>
             <a:r>
-              <a:rPr lang="en-US" sz="1400" b="1" spc="300" kern="0" dirty="0">
+              <a:rPr lang="en-US" sz="1400" b="1" kern="0" spc="300" dirty="0">
                 <a:solidFill>
                   <a:srgbClr val="0F7173"/>
                 </a:solidFill>
@@ -2672,7 +2405,7 @@
           <a:bodyPr wrap="square" lIns="0" tIns="0" rIns="0" bIns="0" rtlCol="0" anchor="ctr"/>
           <a:lstStyle/>
           <a:p>
-            <a:pPr indent="0" marL="0">
+            <a:pPr marL="0" indent="0">
               <a:lnSpc>
                 <a:spcPct val="115000"/>
               </a:lnSpc>
@@ -2692,7 +2425,7 @@
             <a:endParaRPr lang="en-US" sz="3400" dirty="0"/>
           </a:p>
           <a:p>
-            <a:pPr indent="0" marL="0">
+            <a:pPr marL="0" indent="0">
               <a:lnSpc>
                 <a:spcPct val="115000"/>
               </a:lnSpc>
@@ -2734,7 +2467,7 @@
           <a:bodyPr wrap="square" lIns="0" tIns="0" rIns="0" bIns="0" rtlCol="0" anchor="ctr"/>
           <a:lstStyle/>
           <a:p>
-            <a:pPr indent="0" marL="0">
+            <a:pPr marL="0" indent="0">
               <a:buNone/>
             </a:pPr>
             <a:r>
@@ -2790,6 +2523,7 @@
         <a:solidFill>
           <a:srgbClr val="FFFFFF"/>
         </a:solidFill>
+        <a:effectLst/>
       </p:bgPr>
     </p:bg>
     <p:spTree>
@@ -2827,7 +2561,7 @@
           <a:bodyPr wrap="square" lIns="0" tIns="0" rIns="0" bIns="0" rtlCol="0" anchor="ctr"/>
           <a:lstStyle/>
           <a:p>
-            <a:pPr indent="0" marL="0">
+            <a:pPr marL="0" indent="0">
               <a:buNone/>
             </a:pPr>
             <a:r>
@@ -2866,7 +2600,7 @@
           <a:bodyPr wrap="square" lIns="0" tIns="0" rIns="0" bIns="0" rtlCol="0" anchor="ctr"/>
           <a:lstStyle/>
           <a:p>
-            <a:pPr indent="0" marL="0">
+            <a:pPr marL="0" indent="0">
               <a:buNone/>
             </a:pPr>
             <a:r>
@@ -2905,7 +2639,7 @@
           </a:solidFill>
           <a:ln/>
           <a:effectLst>
-            <a:outerShdw sx="100000" sy="100000" kx="0" ky="0" algn="bl" rotWithShape="0" blurRad="101600" dist="38100" dir="5400000">
+            <a:outerShdw blurRad="101600" dist="38100" dir="5400000" algn="bl" rotWithShape="0">
               <a:srgbClr val="000000">
                 <a:alpha val="10000"/>
               </a:srgbClr>
@@ -2915,14 +2649,14 @@
       </p:sp>
       <p:pic>
         <p:nvPicPr>
-          <p:cNvPr id="5" name="Image 0" descr="preencoded.png">    </p:cNvPr>
+          <p:cNvPr id="5" name="Image 0" descr="preencoded.png"/>
           <p:cNvPicPr>
             <a:picLocks noChangeAspect="1"/>
           </p:cNvPicPr>
           <p:nvPr/>
         </p:nvPicPr>
         <p:blipFill>
-          <a:blip r:embed="rId1"/>
+          <a:blip r:embed="rId3"/>
           <a:stretch>
             <a:fillRect/>
           </a:stretch>
@@ -2958,7 +2692,7 @@
           <a:bodyPr wrap="square" lIns="0" tIns="0" rIns="0" bIns="0" rtlCol="0" anchor="ctr"/>
           <a:lstStyle/>
           <a:p>
-            <a:pPr algn="ctr" indent="0" marL="0">
+            <a:pPr marL="0" indent="0" algn="ctr">
               <a:buNone/>
             </a:pPr>
             <a:r>
@@ -2997,7 +2731,7 @@
           <a:bodyPr wrap="square" lIns="0" tIns="0" rIns="0" bIns="0" rtlCol="0" anchor="ctr"/>
           <a:lstStyle/>
           <a:p>
-            <a:pPr algn="ctr" indent="0" marL="0">
+            <a:pPr marL="0" indent="0" algn="ctr">
               <a:buNone/>
             </a:pPr>
             <a:r>
@@ -3036,7 +2770,7 @@
           <a:bodyPr wrap="square" lIns="0" tIns="0" rIns="0" bIns="0" rtlCol="0" anchor="ctr"/>
           <a:lstStyle/>
           <a:p>
-            <a:pPr algn="ctr" indent="0" marL="0">
+            <a:pPr marL="0" indent="0" algn="ctr">
               <a:buNone/>
             </a:pPr>
             <a:r>
@@ -3072,7 +2806,7 @@
           </a:solidFill>
           <a:ln/>
           <a:effectLst>
-            <a:outerShdw sx="100000" sy="100000" kx="0" ky="0" algn="bl" rotWithShape="0" blurRad="101600" dist="38100" dir="5400000">
+            <a:outerShdw blurRad="101600" dist="38100" dir="5400000" algn="bl" rotWithShape="0">
               <a:srgbClr val="000000">
                 <a:alpha val="10000"/>
               </a:srgbClr>
@@ -3082,14 +2816,14 @@
       </p:sp>
       <p:pic>
         <p:nvPicPr>
-          <p:cNvPr id="10" name="Image 1" descr="preencoded.png">    </p:cNvPr>
+          <p:cNvPr id="10" name="Image 1" descr="preencoded.png"/>
           <p:cNvPicPr>
             <a:picLocks noChangeAspect="1"/>
           </p:cNvPicPr>
           <p:nvPr/>
         </p:nvPicPr>
         <p:blipFill>
-          <a:blip r:embed="rId2"/>
+          <a:blip r:embed="rId4"/>
           <a:stretch>
             <a:fillRect/>
           </a:stretch>
@@ -3125,7 +2859,7 @@
           <a:bodyPr wrap="square" lIns="0" tIns="0" rIns="0" bIns="0" rtlCol="0" anchor="ctr"/>
           <a:lstStyle/>
           <a:p>
-            <a:pPr algn="ctr" indent="0" marL="0">
+            <a:pPr marL="0" indent="0" algn="ctr">
               <a:buNone/>
             </a:pPr>
             <a:r>
@@ -3164,7 +2898,7 @@
           <a:bodyPr wrap="square" lIns="0" tIns="0" rIns="0" bIns="0" rtlCol="0" anchor="ctr"/>
           <a:lstStyle/>
           <a:p>
-            <a:pPr algn="ctr" indent="0" marL="0">
+            <a:pPr marL="0" indent="0" algn="ctr">
               <a:buNone/>
             </a:pPr>
             <a:r>
@@ -3203,7 +2937,7 @@
           <a:bodyPr wrap="square" lIns="0" tIns="0" rIns="0" bIns="0" rtlCol="0" anchor="ctr"/>
           <a:lstStyle/>
           <a:p>
-            <a:pPr algn="ctr" indent="0" marL="0">
+            <a:pPr marL="0" indent="0" algn="ctr">
               <a:buNone/>
             </a:pPr>
             <a:r>
@@ -3239,7 +2973,7 @@
           </a:solidFill>
           <a:ln/>
           <a:effectLst>
-            <a:outerShdw sx="100000" sy="100000" kx="0" ky="0" algn="bl" rotWithShape="0" blurRad="101600" dist="38100" dir="5400000">
+            <a:outerShdw blurRad="101600" dist="38100" dir="5400000" algn="bl" rotWithShape="0">
               <a:srgbClr val="000000">
                 <a:alpha val="10000"/>
               </a:srgbClr>
@@ -3249,14 +2983,14 @@
       </p:sp>
       <p:pic>
         <p:nvPicPr>
-          <p:cNvPr id="15" name="Image 2" descr="preencoded.png">    </p:cNvPr>
+          <p:cNvPr id="15" name="Image 2" descr="preencoded.png"/>
           <p:cNvPicPr>
             <a:picLocks noChangeAspect="1"/>
           </p:cNvPicPr>
           <p:nvPr/>
         </p:nvPicPr>
         <p:blipFill>
-          <a:blip r:embed="rId3"/>
+          <a:blip r:embed="rId5"/>
           <a:stretch>
             <a:fillRect/>
           </a:stretch>
@@ -3292,7 +3026,7 @@
           <a:bodyPr wrap="square" lIns="0" tIns="0" rIns="0" bIns="0" rtlCol="0" anchor="ctr"/>
           <a:lstStyle/>
           <a:p>
-            <a:pPr algn="ctr" indent="0" marL="0">
+            <a:pPr marL="0" indent="0" algn="ctr">
               <a:buNone/>
             </a:pPr>
             <a:r>
@@ -3331,7 +3065,7 @@
           <a:bodyPr wrap="square" lIns="0" tIns="0" rIns="0" bIns="0" rtlCol="0" anchor="ctr"/>
           <a:lstStyle/>
           <a:p>
-            <a:pPr algn="ctr" indent="0" marL="0">
+            <a:pPr marL="0" indent="0" algn="ctr">
               <a:buNone/>
             </a:pPr>
             <a:r>
@@ -3370,7 +3104,7 @@
           <a:bodyPr wrap="square" lIns="0" tIns="0" rIns="0" bIns="0" rtlCol="0" anchor="ctr"/>
           <a:lstStyle/>
           <a:p>
-            <a:pPr algn="ctr" indent="0" marL="0">
+            <a:pPr marL="0" indent="0" algn="ctr">
               <a:buNone/>
             </a:pPr>
             <a:r>
@@ -3406,7 +3140,7 @@
           </a:solidFill>
           <a:ln/>
           <a:effectLst>
-            <a:outerShdw sx="100000" sy="100000" kx="0" ky="0" algn="bl" rotWithShape="0" blurRad="101600" dist="38100" dir="5400000">
+            <a:outerShdw blurRad="101600" dist="38100" dir="5400000" algn="bl" rotWithShape="0">
               <a:srgbClr val="000000">
                 <a:alpha val="10000"/>
               </a:srgbClr>
@@ -3416,14 +3150,14 @@
       </p:sp>
       <p:pic>
         <p:nvPicPr>
-          <p:cNvPr id="20" name="Image 3" descr="preencoded.png">    </p:cNvPr>
+          <p:cNvPr id="20" name="Image 3" descr="preencoded.png"/>
           <p:cNvPicPr>
             <a:picLocks noChangeAspect="1"/>
           </p:cNvPicPr>
           <p:nvPr/>
         </p:nvPicPr>
         <p:blipFill>
-          <a:blip r:embed="rId4"/>
+          <a:blip r:embed="rId6"/>
           <a:stretch>
             <a:fillRect/>
           </a:stretch>
@@ -3459,7 +3193,7 @@
           <a:bodyPr wrap="square" lIns="0" tIns="0" rIns="0" bIns="0" rtlCol="0" anchor="ctr"/>
           <a:lstStyle/>
           <a:p>
-            <a:pPr algn="ctr" indent="0" marL="0">
+            <a:pPr marL="0" indent="0" algn="ctr">
               <a:buNone/>
             </a:pPr>
             <a:r>
@@ -3498,7 +3232,7 @@
           <a:bodyPr wrap="square" lIns="0" tIns="0" rIns="0" bIns="0" rtlCol="0" anchor="ctr"/>
           <a:lstStyle/>
           <a:p>
-            <a:pPr algn="ctr" indent="0" marL="0">
+            <a:pPr marL="0" indent="0" algn="ctr">
               <a:buNone/>
             </a:pPr>
             <a:r>
@@ -3537,7 +3271,7 @@
           <a:bodyPr wrap="square" lIns="0" tIns="0" rIns="0" bIns="0" rtlCol="0" anchor="ctr"/>
           <a:lstStyle/>
           <a:p>
-            <a:pPr algn="ctr" indent="0" marL="0">
+            <a:pPr marL="0" indent="0" algn="ctr">
               <a:buNone/>
             </a:pPr>
             <a:r>
@@ -3573,7 +3307,7 @@
           </a:solidFill>
           <a:ln/>
           <a:effectLst>
-            <a:outerShdw sx="100000" sy="100000" kx="0" ky="0" algn="bl" rotWithShape="0" blurRad="101600" dist="38100" dir="5400000">
+            <a:outerShdw blurRad="101600" dist="38100" dir="5400000" algn="bl" rotWithShape="0">
               <a:srgbClr val="000000">
                 <a:alpha val="10000"/>
               </a:srgbClr>
@@ -3583,14 +3317,14 @@
       </p:sp>
       <p:pic>
         <p:nvPicPr>
-          <p:cNvPr id="25" name="Image 4" descr="preencoded.png">    </p:cNvPr>
+          <p:cNvPr id="25" name="Image 4" descr="preencoded.png"/>
           <p:cNvPicPr>
             <a:picLocks noChangeAspect="1"/>
           </p:cNvPicPr>
           <p:nvPr/>
         </p:nvPicPr>
         <p:blipFill>
-          <a:blip r:embed="rId5"/>
+          <a:blip r:embed="rId7"/>
           <a:stretch>
             <a:fillRect/>
           </a:stretch>
@@ -3626,7 +3360,7 @@
           <a:bodyPr wrap="square" lIns="0" tIns="0" rIns="0" bIns="0" rtlCol="0" anchor="ctr"/>
           <a:lstStyle/>
           <a:p>
-            <a:pPr algn="ctr" indent="0" marL="0">
+            <a:pPr marL="0" indent="0" algn="ctr">
               <a:buNone/>
             </a:pPr>
             <a:r>
@@ -3665,7 +3399,7 @@
           <a:bodyPr wrap="square" lIns="0" tIns="0" rIns="0" bIns="0" rtlCol="0" anchor="ctr"/>
           <a:lstStyle/>
           <a:p>
-            <a:pPr algn="ctr" indent="0" marL="0">
+            <a:pPr marL="0" indent="0" algn="ctr">
               <a:buNone/>
             </a:pPr>
             <a:r>
@@ -3704,7 +3438,7 @@
           <a:bodyPr wrap="square" lIns="0" tIns="0" rIns="0" bIns="0" rtlCol="0" anchor="ctr"/>
           <a:lstStyle/>
           <a:p>
-            <a:pPr algn="ctr" indent="0" marL="0">
+            <a:pPr marL="0" indent="0" algn="ctr">
               <a:buNone/>
             </a:pPr>
             <a:r>
@@ -3740,7 +3474,7 @@
           </a:solidFill>
           <a:ln/>
           <a:effectLst>
-            <a:outerShdw sx="100000" sy="100000" kx="0" ky="0" algn="bl" rotWithShape="0" blurRad="101600" dist="38100" dir="5400000">
+            <a:outerShdw blurRad="101600" dist="38100" dir="5400000" algn="bl" rotWithShape="0">
               <a:srgbClr val="000000">
                 <a:alpha val="10000"/>
               </a:srgbClr>
@@ -3750,14 +3484,14 @@
       </p:sp>
       <p:pic>
         <p:nvPicPr>
-          <p:cNvPr id="30" name="Image 5" descr="preencoded.png">    </p:cNvPr>
+          <p:cNvPr id="30" name="Image 5" descr="preencoded.png"/>
           <p:cNvPicPr>
             <a:picLocks noChangeAspect="1"/>
           </p:cNvPicPr>
           <p:nvPr/>
         </p:nvPicPr>
         <p:blipFill>
-          <a:blip r:embed="rId6"/>
+          <a:blip r:embed="rId8"/>
           <a:stretch>
             <a:fillRect/>
           </a:stretch>
@@ -3793,7 +3527,7 @@
           <a:bodyPr wrap="square" lIns="0" tIns="0" rIns="0" bIns="0" rtlCol="0" anchor="ctr"/>
           <a:lstStyle/>
           <a:p>
-            <a:pPr algn="ctr" indent="0" marL="0">
+            <a:pPr marL="0" indent="0" algn="ctr">
               <a:buNone/>
             </a:pPr>
             <a:r>
@@ -3832,7 +3566,7 @@
           <a:bodyPr wrap="square" lIns="0" tIns="0" rIns="0" bIns="0" rtlCol="0" anchor="ctr"/>
           <a:lstStyle/>
           <a:p>
-            <a:pPr algn="ctr" indent="0" marL="0">
+            <a:pPr marL="0" indent="0" algn="ctr">
               <a:buNone/>
             </a:pPr>
             <a:r>
@@ -3871,7 +3605,7 @@
           <a:bodyPr wrap="square" lIns="0" tIns="0" rIns="0" bIns="0" rtlCol="0" anchor="ctr"/>
           <a:lstStyle/>
           <a:p>
-            <a:pPr indent="0" marL="0">
+            <a:pPr marL="0" indent="0">
               <a:buNone/>
             </a:pPr>
             <a:r>
@@ -3883,7 +3617,7 @@
                 <a:ea typeface="Calibri" pitchFamily="34" charset="-122"/>
                 <a:cs typeface="Calibri" pitchFamily="34" charset="-120"/>
               </a:rPr>
-              <a:t>Data quality confirmed: 0 duplicate order IDs  ·  0 nulls on join keys  ·  ~99,441 orders across 9 tables</a:t>
+              <a:t>Data quality confirmed: 0 duplicate order IDs  ·  0 nulls on join keys  ·  99,441 orders across 9 tables</a:t>
             </a:r>
             <a:endParaRPr lang="en-US" sz="1200" dirty="0"/>
           </a:p>
@@ -3905,6 +3639,7 @@
         <a:solidFill>
           <a:srgbClr val="FFFFFF"/>
         </a:solidFill>
+        <a:effectLst/>
       </p:bgPr>
     </p:bg>
     <p:spTree>
@@ -3942,7 +3677,7 @@
           <a:bodyPr wrap="square" lIns="0" tIns="0" rIns="0" bIns="0" rtlCol="0" anchor="ctr"/>
           <a:lstStyle/>
           <a:p>
-            <a:pPr indent="0" marL="0">
+            <a:pPr marL="0" indent="0">
               <a:buNone/>
             </a:pPr>
             <a:r>
@@ -3954,7 +3689,7 @@
                 <a:ea typeface="Cambria" pitchFamily="34" charset="-122"/>
                 <a:cs typeface="Cambria" pitchFamily="34" charset="-120"/>
               </a:rPr>
-              <a:t>Revenue nearly 20×'d in under two years</a:t>
+              <a:t>Revenue grew nearly 20× in under two years</a:t>
             </a:r>
             <a:endParaRPr lang="en-US" sz="2800" dirty="0"/>
           </a:p>
@@ -3981,7 +3716,7 @@
           <a:bodyPr wrap="square" lIns="0" tIns="0" rIns="0" bIns="0" rtlCol="0" anchor="ctr"/>
           <a:lstStyle/>
           <a:p>
-            <a:pPr indent="0" marL="0">
+            <a:pPr marL="0" indent="0">
               <a:buNone/>
             </a:pPr>
             <a:r>
@@ -4001,7 +3736,7 @@
       </p:sp>
       <p:graphicFrame>
         <p:nvGraphicFramePr>
-          <p:cNvPr id="4" name="Chart 0" descr=""/>
+          <p:cNvPr id="4" name="Chart 0"/>
           <p:cNvGraphicFramePr/>
           <p:nvPr/>
         </p:nvGraphicFramePr>
@@ -4009,9 +3744,9 @@
           <a:off x="548640" y="1554480"/>
           <a:ext cx="6949440" cy="3931920"/>
         </p:xfrm>
-        <a:graphic xmlns:a="http://schemas.openxmlformats.org/drawingml/2006/main">
+        <a:graphic>
           <a:graphicData uri="http://schemas.openxmlformats.org/drawingml/2006/chart">
-            <c:chart xmlns:c="http://schemas.openxmlformats.org/drawingml/2006/chart" r:id="rId1"/>
+            <c:chart xmlns:c="http://schemas.openxmlformats.org/drawingml/2006/chart" xmlns:r="http://schemas.openxmlformats.org/officeDocument/2006/relationships" r:id="rId3"/>
           </a:graphicData>
         </a:graphic>
       </p:graphicFrame>
@@ -4058,7 +3793,7 @@
           <a:bodyPr wrap="square" lIns="0" tIns="0" rIns="0" bIns="0" rtlCol="0" anchor="ctr"/>
           <a:lstStyle/>
           <a:p>
-            <a:pPr indent="0" marL="0">
+            <a:pPr marL="0" indent="0">
               <a:buNone/>
             </a:pPr>
             <a:r>
@@ -4070,7 +3805,7 @@
                 <a:ea typeface="Cambria" pitchFamily="34" charset="-122"/>
                 <a:cs typeface="Cambria" pitchFamily="34" charset="-120"/>
               </a:rPr>
-              <a:t>GH₵ 15.7M</a:t>
+              <a:t>GH₵ 33.0M</a:t>
             </a:r>
             <a:endParaRPr lang="en-US" sz="2600" dirty="0"/>
           </a:p>
@@ -4097,7 +3832,7 @@
           <a:bodyPr wrap="square" lIns="0" tIns="0" rIns="0" bIns="0" rtlCol="0" anchor="ctr"/>
           <a:lstStyle/>
           <a:p>
-            <a:pPr indent="0" marL="0">
+            <a:pPr marL="0" indent="0">
               <a:buNone/>
             </a:pPr>
             <a:r>
@@ -4114,7 +3849,7 @@
             <a:endParaRPr lang="en-US" sz="1050" dirty="0"/>
           </a:p>
           <a:p>
-            <a:pPr indent="0" marL="0">
+            <a:pPr marL="0" indent="0">
               <a:buNone/>
             </a:pPr>
             <a:r>
@@ -4175,7 +3910,7 @@
           <a:bodyPr wrap="square" lIns="0" tIns="0" rIns="0" bIns="0" rtlCol="0" anchor="ctr"/>
           <a:lstStyle/>
           <a:p>
-            <a:pPr indent="0" marL="0">
+            <a:pPr marL="0" indent="0">
               <a:buNone/>
             </a:pPr>
             <a:r>
@@ -4187,7 +3922,7 @@
                 <a:ea typeface="Cambria" pitchFamily="34" charset="-122"/>
                 <a:cs typeface="Cambria" pitchFamily="34" charset="-120"/>
               </a:rPr>
-              <a:t>18×</a:t>
+              <a:t>19.4×</a:t>
             </a:r>
             <a:endParaRPr lang="en-US" sz="2600" dirty="0"/>
           </a:p>
@@ -4214,7 +3949,7 @@
           <a:bodyPr wrap="square" lIns="0" tIns="0" rIns="0" bIns="0" rtlCol="0" anchor="ctr"/>
           <a:lstStyle/>
           <a:p>
-            <a:pPr indent="0" marL="0">
+            <a:pPr marL="0" indent="0">
               <a:buNone/>
             </a:pPr>
             <a:r>
@@ -4231,7 +3966,7 @@
             <a:endParaRPr lang="en-US" sz="1050" dirty="0"/>
           </a:p>
           <a:p>
-            <a:pPr indent="0" marL="0">
+            <a:pPr marL="0" indent="0">
               <a:buNone/>
             </a:pPr>
             <a:r>
@@ -4243,7 +3978,7 @@
                 <a:ea typeface="Calibri" pitchFamily="34" charset="-122"/>
                 <a:cs typeface="Calibri" pitchFamily="34" charset="-120"/>
               </a:rPr>
-              <a:t>quarter</a:t>
+              <a:t>full month</a:t>
             </a:r>
             <a:endParaRPr lang="en-US" sz="1050" dirty="0"/>
           </a:p>
@@ -4292,7 +4027,7 @@
           <a:bodyPr wrap="square" lIns="0" tIns="0" rIns="0" bIns="0" rtlCol="0" anchor="ctr"/>
           <a:lstStyle/>
           <a:p>
-            <a:pPr indent="0" marL="0">
+            <a:pPr marL="0" indent="0">
               <a:buNone/>
             </a:pPr>
             <a:r>
@@ -4331,7 +4066,7 @@
           <a:bodyPr wrap="square" lIns="0" tIns="0" rIns="0" bIns="0" rtlCol="0" anchor="ctr"/>
           <a:lstStyle/>
           <a:p>
-            <a:pPr indent="0" marL="0">
+            <a:pPr marL="0" indent="0">
               <a:buNone/>
             </a:pPr>
             <a:r>
@@ -4348,7 +4083,7 @@
             <a:endParaRPr lang="en-US" sz="1050" dirty="0"/>
           </a:p>
           <a:p>
-            <a:pPr indent="0" marL="0">
+            <a:pPr marL="0" indent="0">
               <a:buNone/>
             </a:pPr>
             <a:r>
@@ -4360,7 +4095,46 @@
                 <a:ea typeface="Calibri" pitchFamily="34" charset="-122"/>
                 <a:cs typeface="Calibri" pitchFamily="34" charset="-120"/>
               </a:rPr>
-              <a:t>continuous data</a:t>
+              <a:t>data (Sep '16–Sep '18)</a:t>
+            </a:r>
+            <a:endParaRPr lang="en-US" sz="1050" dirty="0"/>
+          </a:p>
+        </p:txBody>
+      </p:sp>
+      <p:sp>
+        <p:nvSpPr>
+          <p:cNvPr id="14" name="Text 11"/>
+          <p:cNvSpPr/>
+          <p:nvPr/>
+        </p:nvSpPr>
+        <p:spPr>
+          <a:xfrm>
+            <a:off x="548640" y="5623560"/>
+            <a:ext cx="10515600" cy="320040"/>
+          </a:xfrm>
+          <a:prstGeom prst="rect">
+            <a:avLst/>
+          </a:prstGeom>
+          <a:noFill/>
+          <a:ln/>
+        </p:spPr>
+        <p:txBody>
+          <a:bodyPr wrap="square" lIns="0" tIns="0" rIns="0" bIns="0" rtlCol="0" anchor="ctr"/>
+          <a:lstStyle/>
+          <a:p>
+            <a:pPr marL="0" indent="0">
+              <a:buNone/>
+            </a:pPr>
+            <a:r>
+              <a:rPr lang="en-US" sz="1050" i="1" dirty="0">
+                <a:solidFill>
+                  <a:srgbClr val="5C7080"/>
+                </a:solidFill>
+                <a:latin typeface="Calibri" pitchFamily="34" charset="0"/>
+                <a:ea typeface="Calibri" pitchFamily="34" charset="-122"/>
+                <a:cs typeface="Calibri" pitchFamily="34" charset="-120"/>
+              </a:rPr>
+              <a:t>Growth measured Oct 2016 (GH₵107,845) → Aug 2018 (GH₵2,093,644), the first and last full months of data.</a:t>
             </a:r>
             <a:endParaRPr lang="en-US" sz="1050" dirty="0"/>
           </a:p>
@@ -4382,6 +4156,7 @@
         <a:solidFill>
           <a:srgbClr val="0B2545"/>
         </a:solidFill>
+        <a:effectLst/>
       </p:bgPr>
     </p:bg>
     <p:spTree>
@@ -4419,7 +4194,7 @@
           <a:bodyPr wrap="square" lIns="0" tIns="0" rIns="0" bIns="0" rtlCol="0" anchor="ctr"/>
           <a:lstStyle/>
           <a:p>
-            <a:pPr indent="0" marL="0">
+            <a:pPr marL="0" indent="0">
               <a:buNone/>
             </a:pPr>
             <a:r>
@@ -4458,7 +4233,7 @@
           <a:bodyPr wrap="square" lIns="0" tIns="0" rIns="0" bIns="0" rtlCol="0" anchor="ctr"/>
           <a:lstStyle/>
           <a:p>
-            <a:pPr indent="0" marL="0">
+            <a:pPr marL="0" indent="0">
               <a:buNone/>
             </a:pPr>
             <a:r>
@@ -4478,7 +4253,7 @@
       </p:sp>
       <p:graphicFrame>
         <p:nvGraphicFramePr>
-          <p:cNvPr id="4" name="Chart 0" descr=""/>
+          <p:cNvPr id="4" name="Chart 0"/>
           <p:cNvGraphicFramePr/>
           <p:nvPr/>
         </p:nvGraphicFramePr>
@@ -4486,9 +4261,9 @@
           <a:off x="548640" y="1554480"/>
           <a:ext cx="5852160" cy="3931920"/>
         </p:xfrm>
-        <a:graphic xmlns:a="http://schemas.openxmlformats.org/drawingml/2006/main">
+        <a:graphic>
           <a:graphicData uri="http://schemas.openxmlformats.org/drawingml/2006/chart">
-            <c:chart xmlns:c="http://schemas.openxmlformats.org/drawingml/2006/chart" r:id="rId1"/>
+            <c:chart xmlns:c="http://schemas.openxmlformats.org/drawingml/2006/chart" xmlns:r="http://schemas.openxmlformats.org/officeDocument/2006/relationships" r:id="rId3"/>
           </a:graphicData>
         </a:graphic>
       </p:graphicFrame>
@@ -4513,7 +4288,7 @@
           <a:bodyPr wrap="square" lIns="0" tIns="0" rIns="0" bIns="0" rtlCol="0" anchor="ctr"/>
           <a:lstStyle/>
           <a:p>
-            <a:pPr indent="0" marL="0">
+            <a:pPr marL="0" indent="0">
               <a:buNone/>
             </a:pPr>
             <a:r>
@@ -4540,7 +4315,7 @@
         <p:spPr>
           <a:xfrm>
             <a:off x="6766560" y="2148840"/>
-            <a:ext cx="4846320" cy="2286000"/>
+            <a:ext cx="4846320" cy="2468880"/>
           </a:xfrm>
           <a:prstGeom prst="rect">
             <a:avLst/>
@@ -4560,7 +4335,7 @@
               <a:buChar char="•"/>
             </a:pPr>
             <a:r>
-              <a:rPr lang="en-US" sz="1400" dirty="0">
+              <a:rPr lang="en-US" sz="1350" dirty="0">
                 <a:solidFill>
                   <a:srgbClr val="FFFFFF"/>
                 </a:solidFill>
@@ -4568,9 +4343,9 @@
                 <a:ea typeface="Calibri" pitchFamily="34" charset="-122"/>
                 <a:cs typeface="Calibri" pitchFamily="34" charset="-120"/>
               </a:rPr>
-              <a:t>Top-quartile customers spend roughly 8× more than the bottom quartile</a:t>
+              <a:t>Top-quartile customers spend ~9× more than the bottom quartile (GH₵828 vs GH₵92 average)</a:t>
             </a:r>
-            <a:endParaRPr lang="en-US" sz="1400" dirty="0"/>
+            <a:endParaRPr lang="en-US" sz="1350" dirty="0"/>
           </a:p>
           <a:p>
             <a:pPr marL="342900" indent="-342900">
@@ -4581,7 +4356,7 @@
               <a:buChar char="•"/>
             </a:pPr>
             <a:r>
-              <a:rPr lang="en-US" sz="1400" dirty="0">
+              <a:rPr lang="en-US" sz="1350" dirty="0">
                 <a:solidFill>
                   <a:srgbClr val="FFFFFF"/>
                 </a:solidFill>
@@ -4589,9 +4364,9 @@
                 <a:ea typeface="Calibri" pitchFamily="34" charset="-122"/>
                 <a:cs typeface="Calibri" pitchFamily="34" charset="-120"/>
               </a:rPr>
-              <a:t>A small, identifiable segment drives outsized revenue</a:t>
+              <a:t>Q1 customers alone account for GH₵19.7M of the GH₵33.0M total — nearly 60% of all revenue</a:t>
             </a:r>
-            <a:endParaRPr lang="en-US" sz="1400" dirty="0"/>
+            <a:endParaRPr lang="en-US" sz="1350" dirty="0"/>
           </a:p>
           <a:p>
             <a:pPr marL="342900" indent="-342900">
@@ -4602,7 +4377,7 @@
               <a:buChar char="•"/>
             </a:pPr>
             <a:r>
-              <a:rPr lang="en-US" sz="1400" dirty="0">
+              <a:rPr lang="en-US" sz="1350" dirty="0">
                 <a:solidFill>
                   <a:srgbClr val="FFFFFF"/>
                 </a:solidFill>
@@ -4610,22 +4385,22 @@
                 <a:ea typeface="Calibri" pitchFamily="34" charset="-122"/>
                 <a:cs typeface="Calibri" pitchFamily="34" charset="-120"/>
               </a:rPr>
-              <a:t>Retention spend on this group has the highest expected return</a:t>
+              <a:t>A small, identifiable segment drives outsized revenue</a:t>
             </a:r>
-            <a:endParaRPr lang="en-US" sz="1400" dirty="0"/>
+            <a:endParaRPr lang="en-US" sz="1350" dirty="0"/>
           </a:p>
         </p:txBody>
       </p:sp>
       <p:pic>
         <p:nvPicPr>
-          <p:cNvPr id="7" name="Image 0" descr="preencoded.png">    </p:cNvPr>
+          <p:cNvPr id="7" name="Image 0" descr="preencoded.png"/>
           <p:cNvPicPr>
             <a:picLocks noChangeAspect="1"/>
           </p:cNvPicPr>
           <p:nvPr/>
         </p:nvPicPr>
         <p:blipFill>
-          <a:blip r:embed="rId2"/>
+          <a:blip r:embed="rId4"/>
           <a:stretch>
             <a:fillRect/>
           </a:stretch>
@@ -4661,7 +4436,7 @@
           <a:bodyPr wrap="square" lIns="0" tIns="0" rIns="0" bIns="0" rtlCol="0" anchor="ctr"/>
           <a:lstStyle/>
           <a:p>
-            <a:pPr indent="0" marL="0">
+            <a:pPr marL="0" indent="0">
               <a:buNone/>
             </a:pPr>
             <a:r>
@@ -4695,6 +4470,7 @@
         <a:solidFill>
           <a:srgbClr val="FFFFFF"/>
         </a:solidFill>
+        <a:effectLst/>
       </p:bgPr>
     </p:bg>
     <p:spTree>
@@ -4732,7 +4508,7 @@
           <a:bodyPr wrap="square" lIns="0" tIns="0" rIns="0" bIns="0" rtlCol="0" anchor="ctr"/>
           <a:lstStyle/>
           <a:p>
-            <a:pPr indent="0" marL="0">
+            <a:pPr marL="0" indent="0">
               <a:buNone/>
             </a:pPr>
             <a:r>
@@ -4771,7 +4547,7 @@
           <a:bodyPr wrap="square" lIns="0" tIns="0" rIns="0" bIns="0" rtlCol="0" anchor="ctr"/>
           <a:lstStyle/>
           <a:p>
-            <a:pPr indent="0" marL="0">
+            <a:pPr marL="0" indent="0">
               <a:buNone/>
             </a:pPr>
             <a:r>
@@ -4812,9 +4588,27 @@
             <a:tbl>
               <a:tblPr/>
               <a:tblGrid>
-                <a:gridCol w="3840480"/>
-                <a:gridCol w="1554480"/>
-                <a:gridCol w="1280160"/>
+                <a:gridCol w="3840480">
+                  <a:extLst>
+                    <a:ext uri="{9D8B030D-6E8A-4147-A177-3AD203B41FA5}">
+                      <a16:colId xmlns:a16="http://schemas.microsoft.com/office/drawing/2014/main" val="20000"/>
+                    </a:ext>
+                  </a:extLst>
+                </a:gridCol>
+                <a:gridCol w="1828800">
+                  <a:extLst>
+                    <a:ext uri="{9D8B030D-6E8A-4147-A177-3AD203B41FA5}">
+                      <a16:colId xmlns:a16="http://schemas.microsoft.com/office/drawing/2014/main" val="20001"/>
+                    </a:ext>
+                  </a:extLst>
+                </a:gridCol>
+                <a:gridCol w="1005840">
+                  <a:extLst>
+                    <a:ext uri="{9D8B030D-6E8A-4147-A177-3AD203B41FA5}">
+                      <a16:colId xmlns:a16="http://schemas.microsoft.com/office/drawing/2014/main" val="20002"/>
+                    </a:ext>
+                  </a:extLst>
+                </a:gridCol>
               </a:tblGrid>
               <a:tr h="502920">
                 <a:tc>
@@ -4822,7 +4616,7 @@
                     <a:bodyPr/>
                     <a:lstStyle/>
                     <a:p>
-                      <a:pPr indent="0" marL="0">
+                      <a:pPr marL="0" indent="0">
                         <a:buNone/>
                       </a:pPr>
                       <a:r>
@@ -4843,7 +4637,7 @@
                       </a:endParaRPr>
                     </a:p>
                   </a:txBody>
-                  <a:tcPr marL="91440" marR="91440" marT="45720" marB="45720" anchor="ctr">
+                  <a:tcPr anchor="ctr">
                     <a:lnL w="6350" cap="flat" cmpd="sng" algn="ctr">
                       <a:solidFill>
                         <a:srgbClr val="E2E8F0"/>
@@ -4890,11 +4684,11 @@
                     <a:bodyPr/>
                     <a:lstStyle/>
                     <a:p>
-                      <a:pPr algn="ctr" indent="0" marL="0">
+                      <a:pPr marL="0" indent="0" algn="ctr">
                         <a:buNone/>
                       </a:pPr>
                       <a:r>
-                        <a:rPr lang="en-US" sz="1300" b="1" dirty="0">
+                        <a:rPr lang="en-US" sz="1200" b="1" dirty="0">
                           <a:solidFill>
                             <a:srgbClr val="FFFFFF"/>
                           </a:solidFill>
@@ -4902,16 +4696,16 @@
                           <a:ea typeface="Calibri" pitchFamily="34" charset="-122"/>
                           <a:cs typeface="Calibri" pitchFamily="34" charset="-120"/>
                         </a:rPr>
-                        <a:t>Seller Rank</a:t>
+                        <a:t>#1 Seller Revenue (GH₵)</a:t>
                       </a:r>
-                      <a:endParaRPr lang="en-US" sz="1300" dirty="0">
+                      <a:endParaRPr lang="en-US" sz="1200" dirty="0">
                         <a:latin typeface="Calibri" charset="0"/>
                         <a:ea typeface="Calibri" charset="0"/>
                         <a:cs typeface="Calibri" charset="0"/>
                       </a:endParaRPr>
                     </a:p>
                   </a:txBody>
-                  <a:tcPr marL="91440" marR="91440" marT="45720" marB="45720" anchor="ctr">
+                  <a:tcPr anchor="ctr">
                     <a:lnL w="6350" cap="flat" cmpd="sng" algn="ctr">
                       <a:solidFill>
                         <a:srgbClr val="E2E8F0"/>
@@ -4958,7 +4752,7 @@
                     <a:bodyPr/>
                     <a:lstStyle/>
                     <a:p>
-                      <a:pPr algn="ctr" indent="0" marL="0">
+                      <a:pPr marL="0" indent="0" algn="ctr">
                         <a:buNone/>
                       </a:pPr>
                       <a:r>
@@ -4970,7 +4764,7 @@
                           <a:ea typeface="Calibri" pitchFamily="34" charset="-122"/>
                           <a:cs typeface="Calibri" pitchFamily="34" charset="-120"/>
                         </a:rPr>
-                        <a:t>Revenue Share</a:t>
+                        <a:t>Items Sold</a:t>
                       </a:r>
                       <a:endParaRPr lang="en-US" sz="1300" dirty="0">
                         <a:latin typeface="Calibri" charset="0"/>
@@ -4979,7 +4773,7 @@
                       </a:endParaRPr>
                     </a:p>
                   </a:txBody>
-                  <a:tcPr marL="91440" marR="91440" marT="45720" marB="45720" anchor="ctr">
+                  <a:tcPr anchor="ctr">
                     <a:lnL w="6350" cap="flat" cmpd="sng" algn="ctr">
                       <a:solidFill>
                         <a:srgbClr val="E2E8F0"/>
@@ -5021,6 +4815,11 @@
                     </a:solidFill>
                   </a:tcPr>
                 </a:tc>
+                <a:extLst>
+                  <a:ext uri="{0D108BD9-81ED-4DB2-BD59-A6C34878D82A}">
+                    <a16:rowId xmlns:a16="http://schemas.microsoft.com/office/drawing/2014/main" val="10000"/>
+                  </a:ext>
+                </a:extLst>
               </a:tr>
               <a:tr h="502920">
                 <a:tc>
@@ -5028,7 +4827,7 @@
                     <a:bodyPr/>
                     <a:lstStyle/>
                     <a:p>
-                      <a:pPr indent="0" marL="0">
+                      <a:pPr marL="0" indent="0">
                         <a:buNone/>
                       </a:pPr>
                       <a:r>
@@ -5040,7 +4839,7 @@
                           <a:ea typeface="Calibri" pitchFamily="34" charset="-122"/>
                           <a:cs typeface="Calibri" pitchFamily="34" charset="-120"/>
                         </a:rPr>
-                        <a:t>bed_bath_table</a:t>
+                        <a:t>agro_industria_e_comercio</a:t>
                       </a:r>
                       <a:endParaRPr lang="en-US" sz="1200" dirty="0">
                         <a:latin typeface="Calibri" charset="0"/>
@@ -5049,7 +4848,7 @@
                       </a:endParaRPr>
                     </a:p>
                   </a:txBody>
-                  <a:tcPr marL="91440" marR="91440" marT="45720" marB="45720" anchor="ctr">
+                  <a:tcPr anchor="ctr">
                     <a:lnL w="6350" cap="flat" cmpd="sng" algn="ctr">
                       <a:solidFill>
                         <a:srgbClr val="E2E8F0"/>
@@ -5093,7 +4892,7 @@
                     <a:bodyPr/>
                     <a:lstStyle/>
                     <a:p>
-                      <a:pPr algn="ctr" indent="0" marL="0">
+                      <a:pPr marL="0" indent="0" algn="ctr">
                         <a:buNone/>
                       </a:pPr>
                       <a:r>
@@ -5105,7 +4904,7 @@
                           <a:ea typeface="Calibri" pitchFamily="34" charset="-122"/>
                           <a:cs typeface="Calibri" pitchFamily="34" charset="-120"/>
                         </a:rPr>
-                        <a:t>#1 seller</a:t>
+                        <a:t>GH₵66,306</a:t>
                       </a:r>
                       <a:endParaRPr lang="en-US" sz="1200" dirty="0">
                         <a:latin typeface="Calibri" charset="0"/>
@@ -5114,7 +4913,7 @@
                       </a:endParaRPr>
                     </a:p>
                   </a:txBody>
-                  <a:tcPr marL="91440" marR="91440" marT="45720" marB="45720" anchor="ctr">
+                  <a:tcPr anchor="ctr">
                     <a:lnL w="6350" cap="flat" cmpd="sng" algn="ctr">
                       <a:solidFill>
                         <a:srgbClr val="E2E8F0"/>
@@ -5158,7 +4957,7 @@
                     <a:bodyPr/>
                     <a:lstStyle/>
                     <a:p>
-                      <a:pPr algn="ctr" indent="0" marL="0">
+                      <a:pPr marL="0" indent="0" algn="ctr">
                         <a:buNone/>
                       </a:pPr>
                       <a:r>
@@ -5170,7 +4969,7 @@
                           <a:ea typeface="Calibri" pitchFamily="34" charset="-122"/>
                           <a:cs typeface="Calibri" pitchFamily="34" charset="-120"/>
                         </a:rPr>
-                        <a:t>Dominant</a:t>
+                        <a:t>84</a:t>
                       </a:r>
                       <a:endParaRPr lang="en-US" sz="1200" dirty="0">
                         <a:latin typeface="Calibri" charset="0"/>
@@ -5179,7 +4978,7 @@
                       </a:endParaRPr>
                     </a:p>
                   </a:txBody>
-                  <a:tcPr marL="91440" marR="91440" marT="45720" marB="45720" anchor="ctr">
+                  <a:tcPr anchor="ctr">
                     <a:lnL w="6350" cap="flat" cmpd="sng" algn="ctr">
                       <a:solidFill>
                         <a:srgbClr val="E2E8F0"/>
@@ -5218,6 +5017,11 @@
                     </a:lnB>
                   </a:tcPr>
                 </a:tc>
+                <a:extLst>
+                  <a:ext uri="{0D108BD9-81ED-4DB2-BD59-A6C34878D82A}">
+                    <a16:rowId xmlns:a16="http://schemas.microsoft.com/office/drawing/2014/main" val="10001"/>
+                  </a:ext>
+                </a:extLst>
               </a:tr>
               <a:tr h="502920">
                 <a:tc>
@@ -5225,7 +5029,7 @@
                     <a:bodyPr/>
                     <a:lstStyle/>
                     <a:p>
-                      <a:pPr indent="0" marL="0">
+                      <a:pPr marL="0" indent="0">
                         <a:buNone/>
                       </a:pPr>
                       <a:r>
@@ -5237,7 +5041,7 @@
                           <a:ea typeface="Calibri" pitchFamily="34" charset="-122"/>
                           <a:cs typeface="Calibri" pitchFamily="34" charset="-120"/>
                         </a:rPr>
-                        <a:t>health_beauty</a:t>
+                        <a:t>alimentos</a:t>
                       </a:r>
                       <a:endParaRPr lang="en-US" sz="1200" dirty="0">
                         <a:latin typeface="Calibri" charset="0"/>
@@ -5246,7 +5050,7 @@
                       </a:endParaRPr>
                     </a:p>
                   </a:txBody>
-                  <a:tcPr marL="91440" marR="91440" marT="45720" marB="45720" anchor="ctr">
+                  <a:tcPr anchor="ctr">
                     <a:lnL w="6350" cap="flat" cmpd="sng" algn="ctr">
                       <a:solidFill>
                         <a:srgbClr val="E2E8F0"/>
@@ -5290,7 +5094,7 @@
                     <a:bodyPr/>
                     <a:lstStyle/>
                     <a:p>
-                      <a:pPr algn="ctr" indent="0" marL="0">
+                      <a:pPr marL="0" indent="0" algn="ctr">
                         <a:buNone/>
                       </a:pPr>
                       <a:r>
@@ -5302,7 +5106,7 @@
                           <a:ea typeface="Calibri" pitchFamily="34" charset="-122"/>
                           <a:cs typeface="Calibri" pitchFamily="34" charset="-120"/>
                         </a:rPr>
-                        <a:t>#1 seller</a:t>
+                        <a:t>GH₵10,447</a:t>
                       </a:r>
                       <a:endParaRPr lang="en-US" sz="1200" dirty="0">
                         <a:latin typeface="Calibri" charset="0"/>
@@ -5311,7 +5115,7 @@
                       </a:endParaRPr>
                     </a:p>
                   </a:txBody>
-                  <a:tcPr marL="91440" marR="91440" marT="45720" marB="45720" anchor="ctr">
+                  <a:tcPr anchor="ctr">
                     <a:lnL w="6350" cap="flat" cmpd="sng" algn="ctr">
                       <a:solidFill>
                         <a:srgbClr val="E2E8F0"/>
@@ -5355,7 +5159,7 @@
                     <a:bodyPr/>
                     <a:lstStyle/>
                     <a:p>
-                      <a:pPr algn="ctr" indent="0" marL="0">
+                      <a:pPr marL="0" indent="0" algn="ctr">
                         <a:buNone/>
                       </a:pPr>
                       <a:r>
@@ -5367,7 +5171,7 @@
                           <a:ea typeface="Calibri" pitchFamily="34" charset="-122"/>
                           <a:cs typeface="Calibri" pitchFamily="34" charset="-120"/>
                         </a:rPr>
-                        <a:t>Dominant</a:t>
+                        <a:t>99</a:t>
                       </a:r>
                       <a:endParaRPr lang="en-US" sz="1200" dirty="0">
                         <a:latin typeface="Calibri" charset="0"/>
@@ -5376,7 +5180,7 @@
                       </a:endParaRPr>
                     </a:p>
                   </a:txBody>
-                  <a:tcPr marL="91440" marR="91440" marT="45720" marB="45720" anchor="ctr">
+                  <a:tcPr anchor="ctr">
                     <a:lnL w="6350" cap="flat" cmpd="sng" algn="ctr">
                       <a:solidFill>
                         <a:srgbClr val="E2E8F0"/>
@@ -5415,6 +5219,11 @@
                     </a:lnB>
                   </a:tcPr>
                 </a:tc>
+                <a:extLst>
+                  <a:ext uri="{0D108BD9-81ED-4DB2-BD59-A6C34878D82A}">
+                    <a16:rowId xmlns:a16="http://schemas.microsoft.com/office/drawing/2014/main" val="10002"/>
+                  </a:ext>
+                </a:extLst>
               </a:tr>
               <a:tr h="502920">
                 <a:tc>
@@ -5422,7 +5231,7 @@
                     <a:bodyPr/>
                     <a:lstStyle/>
                     <a:p>
-                      <a:pPr indent="0" marL="0">
+                      <a:pPr marL="0" indent="0">
                         <a:buNone/>
                       </a:pPr>
                       <a:r>
@@ -5434,7 +5243,7 @@
                           <a:ea typeface="Calibri" pitchFamily="34" charset="-122"/>
                           <a:cs typeface="Calibri" pitchFamily="34" charset="-120"/>
                         </a:rPr>
-                        <a:t>sports_leisure</a:t>
+                        <a:t>alimentos_bebidas</a:t>
                       </a:r>
                       <a:endParaRPr lang="en-US" sz="1200" dirty="0">
                         <a:latin typeface="Calibri" charset="0"/>
@@ -5443,7 +5252,7 @@
                       </a:endParaRPr>
                     </a:p>
                   </a:txBody>
-                  <a:tcPr marL="91440" marR="91440" marT="45720" marB="45720" anchor="ctr">
+                  <a:tcPr anchor="ctr">
                     <a:lnL w="6350" cap="flat" cmpd="sng" algn="ctr">
                       <a:solidFill>
                         <a:srgbClr val="E2E8F0"/>
@@ -5487,7 +5296,7 @@
                     <a:bodyPr/>
                     <a:lstStyle/>
                     <a:p>
-                      <a:pPr algn="ctr" indent="0" marL="0">
+                      <a:pPr marL="0" indent="0" algn="ctr">
                         <a:buNone/>
                       </a:pPr>
                       <a:r>
@@ -5499,7 +5308,7 @@
                           <a:ea typeface="Calibri" pitchFamily="34" charset="-122"/>
                           <a:cs typeface="Calibri" pitchFamily="34" charset="-120"/>
                         </a:rPr>
-                        <a:t>#1 seller</a:t>
+                        <a:t>GH₵9,676</a:t>
                       </a:r>
                       <a:endParaRPr lang="en-US" sz="1200" dirty="0">
                         <a:latin typeface="Calibri" charset="0"/>
@@ -5508,7 +5317,7 @@
                       </a:endParaRPr>
                     </a:p>
                   </a:txBody>
-                  <a:tcPr marL="91440" marR="91440" marT="45720" marB="45720" anchor="ctr">
+                  <a:tcPr anchor="ctr">
                     <a:lnL w="6350" cap="flat" cmpd="sng" algn="ctr">
                       <a:solidFill>
                         <a:srgbClr val="E2E8F0"/>
@@ -5552,7 +5361,7 @@
                     <a:bodyPr/>
                     <a:lstStyle/>
                     <a:p>
-                      <a:pPr algn="ctr" indent="0" marL="0">
+                      <a:pPr marL="0" indent="0" algn="ctr">
                         <a:buNone/>
                       </a:pPr>
                       <a:r>
@@ -5564,7 +5373,7 @@
                           <a:ea typeface="Calibri" pitchFamily="34" charset="-122"/>
                           <a:cs typeface="Calibri" pitchFamily="34" charset="-120"/>
                         </a:rPr>
-                        <a:t>Dominant</a:t>
+                        <a:t>37</a:t>
                       </a:r>
                       <a:endParaRPr lang="en-US" sz="1200" dirty="0">
                         <a:latin typeface="Calibri" charset="0"/>
@@ -5573,7 +5382,7 @@
                       </a:endParaRPr>
                     </a:p>
                   </a:txBody>
-                  <a:tcPr marL="91440" marR="91440" marT="45720" marB="45720" anchor="ctr">
+                  <a:tcPr anchor="ctr">
                     <a:lnL w="6350" cap="flat" cmpd="sng" algn="ctr">
                       <a:solidFill>
                         <a:srgbClr val="E2E8F0"/>
@@ -5612,6 +5421,11 @@
                     </a:lnB>
                   </a:tcPr>
                 </a:tc>
+                <a:extLst>
+                  <a:ext uri="{0D108BD9-81ED-4DB2-BD59-A6C34878D82A}">
+                    <a16:rowId xmlns:a16="http://schemas.microsoft.com/office/drawing/2014/main" val="10003"/>
+                  </a:ext>
+                </a:extLst>
               </a:tr>
               <a:tr h="502920">
                 <a:tc>
@@ -5619,7 +5433,7 @@
                     <a:bodyPr/>
                     <a:lstStyle/>
                     <a:p>
-                      <a:pPr indent="0" marL="0">
+                      <a:pPr marL="0" indent="0">
                         <a:buNone/>
                       </a:pPr>
                       <a:r>
@@ -5631,7 +5445,7 @@
                           <a:ea typeface="Calibri" pitchFamily="34" charset="-122"/>
                           <a:cs typeface="Calibri" pitchFamily="34" charset="-120"/>
                         </a:rPr>
-                        <a:t>furniture_decor</a:t>
+                        <a:t>artes</a:t>
                       </a:r>
                       <a:endParaRPr lang="en-US" sz="1200" dirty="0">
                         <a:latin typeface="Calibri" charset="0"/>
@@ -5640,7 +5454,7 @@
                       </a:endParaRPr>
                     </a:p>
                   </a:txBody>
-                  <a:tcPr marL="91440" marR="91440" marT="45720" marB="45720" anchor="ctr">
+                  <a:tcPr anchor="ctr">
                     <a:lnL w="6350" cap="flat" cmpd="sng" algn="ctr">
                       <a:solidFill>
                         <a:srgbClr val="E2E8F0"/>
@@ -5684,7 +5498,7 @@
                     <a:bodyPr/>
                     <a:lstStyle/>
                     <a:p>
-                      <a:pPr algn="ctr" indent="0" marL="0">
+                      <a:pPr marL="0" indent="0" algn="ctr">
                         <a:buNone/>
                       </a:pPr>
                       <a:r>
@@ -5696,7 +5510,7 @@
                           <a:ea typeface="Calibri" pitchFamily="34" charset="-122"/>
                           <a:cs typeface="Calibri" pitchFamily="34" charset="-120"/>
                         </a:rPr>
-                        <a:t>#1 seller</a:t>
+                        <a:t>GH₵22,688</a:t>
                       </a:r>
                       <a:endParaRPr lang="en-US" sz="1200" dirty="0">
                         <a:latin typeface="Calibri" charset="0"/>
@@ -5705,7 +5519,7 @@
                       </a:endParaRPr>
                     </a:p>
                   </a:txBody>
-                  <a:tcPr marL="91440" marR="91440" marT="45720" marB="45720" anchor="ctr">
+                  <a:tcPr anchor="ctr">
                     <a:lnL w="6350" cap="flat" cmpd="sng" algn="ctr">
                       <a:solidFill>
                         <a:srgbClr val="E2E8F0"/>
@@ -5749,7 +5563,7 @@
                     <a:bodyPr/>
                     <a:lstStyle/>
                     <a:p>
-                      <a:pPr algn="ctr" indent="0" marL="0">
+                      <a:pPr marL="0" indent="0" algn="ctr">
                         <a:buNone/>
                       </a:pPr>
                       <a:r>
@@ -5761,7 +5575,7 @@
                           <a:ea typeface="Calibri" pitchFamily="34" charset="-122"/>
                           <a:cs typeface="Calibri" pitchFamily="34" charset="-120"/>
                         </a:rPr>
-                        <a:t>Dominant</a:t>
+                        <a:t>107</a:t>
                       </a:r>
                       <a:endParaRPr lang="en-US" sz="1200" dirty="0">
                         <a:latin typeface="Calibri" charset="0"/>
@@ -5770,7 +5584,7 @@
                       </a:endParaRPr>
                     </a:p>
                   </a:txBody>
-                  <a:tcPr marL="91440" marR="91440" marT="45720" marB="45720" anchor="ctr">
+                  <a:tcPr anchor="ctr">
                     <a:lnL w="6350" cap="flat" cmpd="sng" algn="ctr">
                       <a:solidFill>
                         <a:srgbClr val="E2E8F0"/>
@@ -5809,6 +5623,11 @@
                     </a:lnB>
                   </a:tcPr>
                 </a:tc>
+                <a:extLst>
+                  <a:ext uri="{0D108BD9-81ED-4DB2-BD59-A6C34878D82A}">
+                    <a16:rowId xmlns:a16="http://schemas.microsoft.com/office/drawing/2014/main" val="10004"/>
+                  </a:ext>
+                </a:extLst>
               </a:tr>
               <a:tr h="502920">
                 <a:tc>
@@ -5816,7 +5635,7 @@
                     <a:bodyPr/>
                     <a:lstStyle/>
                     <a:p>
-                      <a:pPr indent="0" marL="0">
+                      <a:pPr marL="0" indent="0">
                         <a:buNone/>
                       </a:pPr>
                       <a:r>
@@ -5828,7 +5647,7 @@
                           <a:ea typeface="Calibri" pitchFamily="34" charset="-122"/>
                           <a:cs typeface="Calibri" pitchFamily="34" charset="-120"/>
                         </a:rPr>
-                        <a:t>computers_accessories</a:t>
+                        <a:t>artes_e_artesanato</a:t>
                       </a:r>
                       <a:endParaRPr lang="en-US" sz="1200" dirty="0">
                         <a:latin typeface="Calibri" charset="0"/>
@@ -5837,7 +5656,7 @@
                       </a:endParaRPr>
                     </a:p>
                   </a:txBody>
-                  <a:tcPr marL="91440" marR="91440" marT="45720" marB="45720" anchor="ctr">
+                  <a:tcPr anchor="ctr">
                     <a:lnL w="6350" cap="flat" cmpd="sng" algn="ctr">
                       <a:solidFill>
                         <a:srgbClr val="E2E8F0"/>
@@ -5881,7 +5700,7 @@
                     <a:bodyPr/>
                     <a:lstStyle/>
                     <a:p>
-                      <a:pPr algn="ctr" indent="0" marL="0">
+                      <a:pPr marL="0" indent="0" algn="ctr">
                         <a:buNone/>
                       </a:pPr>
                       <a:r>
@@ -5893,7 +5712,7 @@
                           <a:ea typeface="Calibri" pitchFamily="34" charset="-122"/>
                           <a:cs typeface="Calibri" pitchFamily="34" charset="-120"/>
                         </a:rPr>
-                        <a:t>#1 seller</a:t>
+                        <a:t>GH₵1,382</a:t>
                       </a:r>
                       <a:endParaRPr lang="en-US" sz="1200" dirty="0">
                         <a:latin typeface="Calibri" charset="0"/>
@@ -5902,7 +5721,7 @@
                       </a:endParaRPr>
                     </a:p>
                   </a:txBody>
-                  <a:tcPr marL="91440" marR="91440" marT="45720" marB="45720" anchor="ctr">
+                  <a:tcPr anchor="ctr">
                     <a:lnL w="6350" cap="flat" cmpd="sng" algn="ctr">
                       <a:solidFill>
                         <a:srgbClr val="E2E8F0"/>
@@ -5946,7 +5765,7 @@
                     <a:bodyPr/>
                     <a:lstStyle/>
                     <a:p>
-                      <a:pPr algn="ctr" indent="0" marL="0">
+                      <a:pPr marL="0" indent="0" algn="ctr">
                         <a:buNone/>
                       </a:pPr>
                       <a:r>
@@ -5958,7 +5777,7 @@
                           <a:ea typeface="Calibri" pitchFamily="34" charset="-122"/>
                           <a:cs typeface="Calibri" pitchFamily="34" charset="-120"/>
                         </a:rPr>
-                        <a:t>Dominant</a:t>
+                        <a:t>6</a:t>
                       </a:r>
                       <a:endParaRPr lang="en-US" sz="1200" dirty="0">
                         <a:latin typeface="Calibri" charset="0"/>
@@ -5967,7 +5786,7 @@
                       </a:endParaRPr>
                     </a:p>
                   </a:txBody>
-                  <a:tcPr marL="91440" marR="91440" marT="45720" marB="45720" anchor="ctr">
+                  <a:tcPr anchor="ctr">
                     <a:lnL w="6350" cap="flat" cmpd="sng" algn="ctr">
                       <a:solidFill>
                         <a:srgbClr val="E2E8F0"/>
@@ -6006,6 +5825,11 @@
                     </a:lnB>
                   </a:tcPr>
                 </a:tc>
+                <a:extLst>
+                  <a:ext uri="{0D108BD9-81ED-4DB2-BD59-A6C34878D82A}">
+                    <a16:rowId xmlns:a16="http://schemas.microsoft.com/office/drawing/2014/main" val="10005"/>
+                  </a:ext>
+                </a:extLst>
               </a:tr>
             </a:tbl>
           </a:graphicData>
@@ -6035,14 +5859,14 @@
       </p:sp>
       <p:pic>
         <p:nvPicPr>
-          <p:cNvPr id="6" name="Image 0" descr="preencoded.png">    </p:cNvPr>
+          <p:cNvPr id="4" name="Image 0" descr="preencoded.png"/>
           <p:cNvPicPr>
             <a:picLocks noChangeAspect="1"/>
           </p:cNvPicPr>
           <p:nvPr/>
         </p:nvPicPr>
         <p:blipFill>
-          <a:blip r:embed="rId1"/>
+          <a:blip r:embed="rId3"/>
           <a:stretch>
             <a:fillRect/>
           </a:stretch>
@@ -6078,7 +5902,7 @@
           <a:bodyPr wrap="square" lIns="0" tIns="0" rIns="0" bIns="0" rtlCol="0" anchor="ctr"/>
           <a:lstStyle/>
           <a:p>
-            <a:pPr indent="0" marL="0">
+            <a:pPr marL="0" indent="0">
               <a:buNone/>
             </a:pPr>
             <a:r>
@@ -6117,7 +5941,7 @@
           <a:bodyPr wrap="square" lIns="0" tIns="0" rIns="0" bIns="0" rtlCol="0" anchor="ctr"/>
           <a:lstStyle/>
           <a:p>
-            <a:pPr indent="0" marL="0">
+            <a:pPr marL="0" indent="0">
               <a:lnSpc>
                 <a:spcPct val="120000"/>
               </a:lnSpc>
@@ -6132,7 +5956,7 @@
                 <a:ea typeface="Calibri" pitchFamily="34" charset="-122"/>
                 <a:cs typeface="Calibri" pitchFamily="34" charset="-120"/>
               </a:rPr>
-              <a:t>Each category is led by a small number of top-ranked sellers who capture the majority of category revenue. These sellers are the natural partners for co-marketing, featured placement, and priority fulfillment support — boosting them has category-wide upside.</a:t>
+              <a:t>A single top-ranked seller per category can generate tens of thousands in revenue from under 100 items. These sellers are the natural partners for co-marketing, featured placement, and priority fulfillment support — boosting them has category-wide upside.</a:t>
             </a:r>
             <a:endParaRPr lang="en-US" sz="1250" dirty="0"/>
           </a:p>
@@ -6159,7 +5983,7 @@
           <a:bodyPr wrap="square" lIns="0" tIns="0" rIns="0" bIns="0" rtlCol="0" anchor="ctr"/>
           <a:lstStyle/>
           <a:p>
-            <a:pPr indent="0" marL="0">
+            <a:pPr marL="0" indent="0">
               <a:buNone/>
             </a:pPr>
             <a:r>
@@ -6171,7 +5995,7 @@
                 <a:ea typeface="Calibri" pitchFamily="34" charset="-122"/>
                 <a:cs typeface="Calibri" pitchFamily="34" charset="-120"/>
               </a:rPr>
-              <a:t>Method: JOIN order_items → products → sellers, then RANK() partitioned by category, ordered by revenue.</a:t>
+              <a:t>Method: JOIN order_items → products → sellers, then RANK() partitioned by category, ordered by revenue. Sample of 5 categories shown; GH₵ at 2.10 BRL rate.</a:t>
             </a:r>
             <a:endParaRPr lang="en-US" sz="1100" dirty="0"/>
           </a:p>
@@ -6193,6 +6017,7 @@
         <a:solidFill>
           <a:srgbClr val="FFFFFF"/>
         </a:solidFill>
+        <a:effectLst/>
       </p:bgPr>
     </p:bg>
     <p:spTree>
@@ -6230,7 +6055,7 @@
           <a:bodyPr wrap="square" lIns="0" tIns="0" rIns="0" bIns="0" rtlCol="0" anchor="ctr"/>
           <a:lstStyle/>
           <a:p>
-            <a:pPr indent="0" marL="0">
+            <a:pPr marL="0" indent="0">
               <a:buNone/>
             </a:pPr>
             <a:r>
@@ -6269,7 +6094,7 @@
           <a:bodyPr wrap="square" lIns="0" tIns="0" rIns="0" bIns="0" rtlCol="0" anchor="ctr"/>
           <a:lstStyle/>
           <a:p>
-            <a:pPr indent="0" marL="0">
+            <a:pPr marL="0" indent="0">
               <a:buNone/>
             </a:pPr>
             <a:r>
@@ -6289,7 +6114,7 @@
       </p:sp>
       <p:graphicFrame>
         <p:nvGraphicFramePr>
-          <p:cNvPr id="4" name="Chart 0" descr=""/>
+          <p:cNvPr id="4" name="Chart 0"/>
           <p:cNvGraphicFramePr/>
           <p:nvPr/>
         </p:nvGraphicFramePr>
@@ -6297,15 +6122,15 @@
           <a:off x="548640" y="1554480"/>
           <a:ext cx="5029200" cy="3200400"/>
         </p:xfrm>
-        <a:graphic xmlns:a="http://schemas.openxmlformats.org/drawingml/2006/main">
+        <a:graphic>
           <a:graphicData uri="http://schemas.openxmlformats.org/drawingml/2006/chart">
-            <c:chart xmlns:c="http://schemas.openxmlformats.org/drawingml/2006/chart" r:id="rId1"/>
+            <c:chart xmlns:c="http://schemas.openxmlformats.org/drawingml/2006/chart" xmlns:r="http://schemas.openxmlformats.org/officeDocument/2006/relationships" r:id="rId3"/>
           </a:graphicData>
         </a:graphic>
       </p:graphicFrame>
       <p:graphicFrame>
         <p:nvGraphicFramePr>
-          <p:cNvPr id="5" name="Chart 1" descr=""/>
+          <p:cNvPr id="5" name="Chart 1"/>
           <p:cNvGraphicFramePr/>
           <p:nvPr/>
         </p:nvGraphicFramePr>
@@ -6313,22 +6138,22 @@
           <a:off x="5852160" y="1554480"/>
           <a:ext cx="5029200" cy="3200400"/>
         </p:xfrm>
-        <a:graphic xmlns:a="http://schemas.openxmlformats.org/drawingml/2006/main">
+        <a:graphic>
           <a:graphicData uri="http://schemas.openxmlformats.org/drawingml/2006/chart">
-            <c:chart xmlns:c="http://schemas.openxmlformats.org/drawingml/2006/chart" r:id="rId2"/>
+            <c:chart xmlns:c="http://schemas.openxmlformats.org/drawingml/2006/chart" xmlns:r="http://schemas.openxmlformats.org/officeDocument/2006/relationships" r:id="rId4"/>
           </a:graphicData>
         </a:graphic>
       </p:graphicFrame>
       <p:pic>
         <p:nvPicPr>
-          <p:cNvPr id="6" name="Image 0" descr="preencoded.png">    </p:cNvPr>
+          <p:cNvPr id="6" name="Image 0" descr="preencoded.png"/>
           <p:cNvPicPr>
             <a:picLocks noChangeAspect="1"/>
           </p:cNvPicPr>
           <p:nvPr/>
         </p:nvPicPr>
         <p:blipFill>
-          <a:blip r:embed="rId3"/>
+          <a:blip r:embed="rId5"/>
           <a:stretch>
             <a:fillRect/>
           </a:stretch>
@@ -6364,7 +6189,7 @@
           <a:bodyPr wrap="square" lIns="0" tIns="0" rIns="0" bIns="0" rtlCol="0" anchor="ctr"/>
           <a:lstStyle/>
           <a:p>
-            <a:pPr indent="0" marL="0">
+            <a:pPr marL="0" indent="0">
               <a:buNone/>
             </a:pPr>
             <a:r>
@@ -6398,6 +6223,7 @@
         <a:solidFill>
           <a:srgbClr val="0B2545"/>
         </a:solidFill>
+        <a:effectLst/>
       </p:bgPr>
     </p:bg>
     <p:spTree>
@@ -6416,14 +6242,14 @@
       </p:grpSpPr>
       <p:pic>
         <p:nvPicPr>
-          <p:cNvPr id="2" name="Image 0" descr="preencoded.png">    </p:cNvPr>
+          <p:cNvPr id="2" name="Image 0" descr="preencoded.png"/>
           <p:cNvPicPr>
             <a:picLocks noChangeAspect="1"/>
           </p:cNvPicPr>
           <p:nvPr/>
         </p:nvPicPr>
         <p:blipFill>
-          <a:blip r:embed="rId1">
+          <a:blip r:embed="rId3">
             <a:alphaModFix amt="90000"/>
           </a:blip>
           <a:stretch>
@@ -6461,11 +6287,11 @@
           <a:bodyPr wrap="square" lIns="0" tIns="0" rIns="0" bIns="0" rtlCol="0" anchor="ctr"/>
           <a:lstStyle/>
           <a:p>
-            <a:pPr indent="0" marL="0">
+            <a:pPr marL="0" indent="0">
               <a:buNone/>
             </a:pPr>
             <a:r>
-              <a:rPr lang="en-US" sz="1400" b="1" spc="300" kern="0" dirty="0">
+              <a:rPr lang="en-US" sz="1400" b="1" kern="0" spc="300" dirty="0">
                 <a:solidFill>
                   <a:srgbClr val="0F7173"/>
                 </a:solidFill>
@@ -6500,7 +6326,7 @@
           <a:bodyPr wrap="square" lIns="0" tIns="0" rIns="0" bIns="0" rtlCol="0" anchor="ctr"/>
           <a:lstStyle/>
           <a:p>
-            <a:pPr indent="0" marL="0">
+            <a:pPr marL="0" indent="0">
               <a:buNone/>
             </a:pPr>
             <a:r>
@@ -6542,14 +6368,14 @@
       </p:sp>
       <p:pic>
         <p:nvPicPr>
-          <p:cNvPr id="6" name="Image 1" descr="preencoded.png">    </p:cNvPr>
+          <p:cNvPr id="6" name="Image 1" descr="preencoded.png"/>
           <p:cNvPicPr>
             <a:picLocks noChangeAspect="1"/>
           </p:cNvPicPr>
           <p:nvPr/>
         </p:nvPicPr>
         <p:blipFill>
-          <a:blip r:embed="rId2"/>
+          <a:blip r:embed="rId4"/>
           <a:stretch>
             <a:fillRect/>
           </a:stretch>
@@ -6585,7 +6411,7 @@
           <a:bodyPr wrap="square" lIns="0" tIns="0" rIns="0" bIns="0" rtlCol="0" anchor="ctr"/>
           <a:lstStyle/>
           <a:p>
-            <a:pPr indent="0" marL="0">
+            <a:pPr marL="0" indent="0">
               <a:lnSpc>
                 <a:spcPct val="110000"/>
               </a:lnSpc>
@@ -6627,7 +6453,7 @@
           <a:bodyPr wrap="square" lIns="0" tIns="0" rIns="0" bIns="0" rtlCol="0" anchor="ctr"/>
           <a:lstStyle/>
           <a:p>
-            <a:pPr indent="0" marL="0">
+            <a:pPr marL="0" indent="0">
               <a:lnSpc>
                 <a:spcPct val="125000"/>
               </a:lnSpc>
@@ -6642,7 +6468,7 @@
                 <a:ea typeface="Calibri" pitchFamily="34" charset="-122"/>
                 <a:cs typeface="Calibri" pitchFamily="34" charset="-120"/>
               </a:rPr>
-              <a:t>Q1 customers spend ~8× the bottom quartile. Launch a loyalty offer targeted at this segment — highest expected return per dollar spent.</a:t>
+              <a:t>Q1 customers spend ~9× the bottom quartile (GH₵828 vs GH₵92 avg) and drive ~60% of total revenue. Launch a targeted loyalty offer — highest expected return per dollar spent.</a:t>
             </a:r>
             <a:endParaRPr lang="en-US" sz="1200" dirty="0"/>
           </a:p>
@@ -6672,14 +6498,14 @@
       </p:sp>
       <p:pic>
         <p:nvPicPr>
-          <p:cNvPr id="10" name="Image 2" descr="preencoded.png">    </p:cNvPr>
+          <p:cNvPr id="10" name="Image 2" descr="preencoded.png"/>
           <p:cNvPicPr>
             <a:picLocks noChangeAspect="1"/>
           </p:cNvPicPr>
           <p:nvPr/>
         </p:nvPicPr>
         <p:blipFill>
-          <a:blip r:embed="rId3"/>
+          <a:blip r:embed="rId5"/>
           <a:stretch>
             <a:fillRect/>
           </a:stretch>
@@ -6715,7 +6541,7 @@
           <a:bodyPr wrap="square" lIns="0" tIns="0" rIns="0" bIns="0" rtlCol="0" anchor="ctr"/>
           <a:lstStyle/>
           <a:p>
-            <a:pPr indent="0" marL="0">
+            <a:pPr marL="0" indent="0">
               <a:lnSpc>
                 <a:spcPct val="110000"/>
               </a:lnSpc>
@@ -6757,7 +6583,7 @@
           <a:bodyPr wrap="square" lIns="0" tIns="0" rIns="0" bIns="0" rtlCol="0" anchor="ctr"/>
           <a:lstStyle/>
           <a:p>
-            <a:pPr indent="0" marL="0">
+            <a:pPr marL="0" indent="0">
               <a:lnSpc>
                 <a:spcPct val="125000"/>
               </a:lnSpc>
@@ -6802,14 +6628,14 @@
       </p:sp>
       <p:pic>
         <p:nvPicPr>
-          <p:cNvPr id="14" name="Image 3" descr="preencoded.png">    </p:cNvPr>
+          <p:cNvPr id="14" name="Image 3" descr="preencoded.png"/>
           <p:cNvPicPr>
             <a:picLocks noChangeAspect="1"/>
           </p:cNvPicPr>
           <p:nvPr/>
         </p:nvPicPr>
         <p:blipFill>
-          <a:blip r:embed="rId4"/>
+          <a:blip r:embed="rId6"/>
           <a:stretch>
             <a:fillRect/>
           </a:stretch>
@@ -6845,7 +6671,7 @@
           <a:bodyPr wrap="square" lIns="0" tIns="0" rIns="0" bIns="0" rtlCol="0" anchor="ctr"/>
           <a:lstStyle/>
           <a:p>
-            <a:pPr indent="0" marL="0">
+            <a:pPr marL="0" indent="0">
               <a:lnSpc>
                 <a:spcPct val="110000"/>
               </a:lnSpc>
@@ -6887,7 +6713,7 @@
           <a:bodyPr wrap="square" lIns="0" tIns="0" rIns="0" bIns="0" rtlCol="0" anchor="ctr"/>
           <a:lstStyle/>
           <a:p>
-            <a:pPr indent="0" marL="0">
+            <a:pPr marL="0" indent="0">
               <a:lnSpc>
                 <a:spcPct val="125000"/>
               </a:lnSpc>
@@ -6902,7 +6728,7 @@
                 <a:ea typeface="Calibri" pitchFamily="34" charset="-122"/>
                 <a:cs typeface="Calibri" pitchFamily="34" charset="-120"/>
               </a:rPr>
-              <a:t>A small set of top-ranked sellers dominates each category. Prioritize them for co-marketing and featured placement to compound category growth.</a:t>
+              <a:t>A single top-ranked seller can generate GH₵66K+ from under 100 items. Prioritize these sellers for co-marketing and featured placement to compound category growth.</a:t>
             </a:r>
             <a:endParaRPr lang="en-US" sz="1200" dirty="0"/>
           </a:p>
@@ -6929,7 +6755,7 @@
           <a:bodyPr wrap="square" lIns="0" tIns="0" rIns="0" bIns="0" rtlCol="0" anchor="ctr"/>
           <a:lstStyle/>
           <a:p>
-            <a:pPr indent="0" marL="0">
+            <a:pPr marL="0" indent="0">
               <a:buNone/>
             </a:pPr>
             <a:r>
@@ -7248,4 +7074,299 @@
     </a:ext>
   </a:extLst>
 </a:theme>
+</file>
+
+<file path=ppt/theme/theme2.xml><?xml version="1.0" encoding="utf-8"?>
+<a:theme xmlns:a="http://schemas.openxmlformats.org/drawingml/2006/main" name="Office Theme">
+  <a:themeElements>
+    <a:clrScheme name="Office">
+      <a:dk1>
+        <a:sysClr val="windowText" lastClr="000000"/>
+      </a:dk1>
+      <a:lt1>
+        <a:sysClr val="window" lastClr="FFFFFF"/>
+      </a:lt1>
+      <a:dk2>
+        <a:srgbClr val="44546A"/>
+      </a:dk2>
+      <a:lt2>
+        <a:srgbClr val="E7E6E6"/>
+      </a:lt2>
+      <a:accent1>
+        <a:srgbClr val="4472C4"/>
+      </a:accent1>
+      <a:accent2>
+        <a:srgbClr val="ED7D31"/>
+      </a:accent2>
+      <a:accent3>
+        <a:srgbClr val="A5A5A5"/>
+      </a:accent3>
+      <a:accent4>
+        <a:srgbClr val="FFC000"/>
+      </a:accent4>
+      <a:accent5>
+        <a:srgbClr val="5B9BD5"/>
+      </a:accent5>
+      <a:accent6>
+        <a:srgbClr val="70AD47"/>
+      </a:accent6>
+      <a:hlink>
+        <a:srgbClr val="0563C1"/>
+      </a:hlink>
+      <a:folHlink>
+        <a:srgbClr val="954F72"/>
+      </a:folHlink>
+    </a:clrScheme>
+    <a:fontScheme name="Office">
+      <a:majorFont>
+        <a:latin typeface="Calibri Light" panose="020F0302020204030204"/>
+        <a:ea typeface=""/>
+        <a:cs typeface=""/>
+        <a:font script="Jpan" typeface="游ゴシック Light"/>
+        <a:font script="Hang" typeface="맑은 고딕"/>
+        <a:font script="Hans" typeface="等线 Light"/>
+        <a:font script="Hant" typeface="新細明體"/>
+        <a:font script="Arab" typeface="Times New Roman"/>
+        <a:font script="Hebr" typeface="Times New Roman"/>
+        <a:font script="Thai" typeface="Angsana New"/>
+        <a:font script="Ethi" typeface="Nyala"/>
+        <a:font script="Beng" typeface="Vrinda"/>
+        <a:font script="Gujr" typeface="Shruti"/>
+        <a:font script="Khmr" typeface="MoolBoran"/>
+        <a:font script="Knda" typeface="Tunga"/>
+        <a:font script="Guru" typeface="Raavi"/>
+        <a:font script="Cans" typeface="Euphemia"/>
+        <a:font script="Cher" typeface="Plantagenet Cherokee"/>
+        <a:font script="Yiii" typeface="Microsoft Yi Baiti"/>
+        <a:font script="Tibt" typeface="Microsoft Himalaya"/>
+        <a:font script="Thaa" typeface="MV Boli"/>
+        <a:font script="Deva" typeface="Mangal"/>
+        <a:font script="Telu" typeface="Gautami"/>
+        <a:font script="Taml" typeface="Latha"/>
+        <a:font script="Syrc" typeface="Estrangelo Edessa"/>
+        <a:font script="Orya" typeface="Kalinga"/>
+        <a:font script="Mlym" typeface="Kartika"/>
+        <a:font script="Laoo" typeface="DokChampa"/>
+        <a:font script="Sinh" typeface="Iskoola Pota"/>
+        <a:font script="Mong" typeface="Mongolian Baiti"/>
+        <a:font script="Viet" typeface="Times New Roman"/>
+        <a:font script="Uigh" typeface="Microsoft Uighur"/>
+        <a:font script="Geor" typeface="Sylfaen"/>
+        <a:font script="Armn" typeface="Arial"/>
+        <a:font script="Bugi" typeface="Leelawadee UI"/>
+        <a:font script="Bopo" typeface="Microsoft JhengHei"/>
+        <a:font script="Java" typeface="Javanese Text"/>
+        <a:font script="Lisu" typeface="Segoe UI"/>
+        <a:font script="Mymr" typeface="Myanmar Text"/>
+        <a:font script="Nkoo" typeface="Ebrima"/>
+        <a:font script="Olck" typeface="Nirmala UI"/>
+        <a:font script="Osma" typeface="Ebrima"/>
+        <a:font script="Phag" typeface="Phagspa"/>
+        <a:font script="Syrn" typeface="Estrangelo Edessa"/>
+        <a:font script="Syrj" typeface="Estrangelo Edessa"/>
+        <a:font script="Syre" typeface="Estrangelo Edessa"/>
+        <a:font script="Sora" typeface="Nirmala UI"/>
+        <a:font script="Tale" typeface="Microsoft Tai Le"/>
+        <a:font script="Talu" typeface="Microsoft New Tai Lue"/>
+        <a:font script="Tfng" typeface="Ebrima"/>
+      </a:majorFont>
+      <a:minorFont>
+        <a:latin typeface="Calibri" panose="020F0502020204030204"/>
+        <a:ea typeface=""/>
+        <a:cs typeface=""/>
+        <a:font script="Jpan" typeface="游ゴシック"/>
+        <a:font script="Hang" typeface="맑은 고딕"/>
+        <a:font script="Hans" typeface="等线"/>
+        <a:font script="Hant" typeface="新細明體"/>
+        <a:font script="Arab" typeface="Arial"/>
+        <a:font script="Hebr" typeface="Arial"/>
+        <a:font script="Thai" typeface="Cordia New"/>
+        <a:font script="Ethi" typeface="Nyala"/>
+        <a:font script="Beng" typeface="Vrinda"/>
+        <a:font script="Gujr" typeface="Shruti"/>
+        <a:font script="Khmr" typeface="DaunPenh"/>
+        <a:font script="Knda" typeface="Tunga"/>
+        <a:font script="Guru" typeface="Raavi"/>
+        <a:font script="Cans" typeface="Euphemia"/>
+        <a:font script="Cher" typeface="Plantagenet Cherokee"/>
+        <a:font script="Yiii" typeface="Microsoft Yi Baiti"/>
+        <a:font script="Tibt" typeface="Microsoft Himalaya"/>
+        <a:font script="Thaa" typeface="MV Boli"/>
+        <a:font script="Deva" typeface="Mangal"/>
+        <a:font script="Telu" typeface="Gautami"/>
+        <a:font script="Taml" typeface="Latha"/>
+        <a:font script="Syrc" typeface="Estrangelo Edessa"/>
+        <a:font script="Orya" typeface="Kalinga"/>
+        <a:font script="Mlym" typeface="Kartika"/>
+        <a:font script="Laoo" typeface="DokChampa"/>
+        <a:font script="Sinh" typeface="Iskoola Pota"/>
+        <a:font script="Mong" typeface="Mongolian Baiti"/>
+        <a:font script="Viet" typeface="Arial"/>
+        <a:font script="Uigh" typeface="Microsoft Uighur"/>
+        <a:font script="Geor" typeface="Sylfaen"/>
+        <a:font script="Armn" typeface="Arial"/>
+        <a:font script="Bugi" typeface="Leelawadee UI"/>
+        <a:font script="Bopo" typeface="Microsoft JhengHei"/>
+        <a:font script="Java" typeface="Javanese Text"/>
+        <a:font script="Lisu" typeface="Segoe UI"/>
+        <a:font script="Mymr" typeface="Myanmar Text"/>
+        <a:font script="Nkoo" typeface="Ebrima"/>
+        <a:font script="Olck" typeface="Nirmala UI"/>
+        <a:font script="Osma" typeface="Ebrima"/>
+        <a:font script="Phag" typeface="Phagspa"/>
+        <a:font script="Syrn" typeface="Estrangelo Edessa"/>
+        <a:font script="Syrj" typeface="Estrangelo Edessa"/>
+        <a:font script="Syre" typeface="Estrangelo Edessa"/>
+        <a:font script="Sora" typeface="Nirmala UI"/>
+        <a:font script="Tale" typeface="Microsoft Tai Le"/>
+        <a:font script="Talu" typeface="Microsoft New Tai Lue"/>
+        <a:font script="Tfng" typeface="Ebrima"/>
+      </a:minorFont>
+    </a:fontScheme>
+    <a:fmtScheme name="Office">
+      <a:fillStyleLst>
+        <a:solidFill>
+          <a:schemeClr val="phClr"/>
+        </a:solidFill>
+        <a:gradFill rotWithShape="1">
+          <a:gsLst>
+            <a:gs pos="0">
+              <a:schemeClr val="phClr">
+                <a:lumMod val="110000"/>
+                <a:satMod val="105000"/>
+                <a:tint val="67000"/>
+              </a:schemeClr>
+            </a:gs>
+            <a:gs pos="50000">
+              <a:schemeClr val="phClr">
+                <a:lumMod val="105000"/>
+                <a:satMod val="103000"/>
+                <a:tint val="73000"/>
+              </a:schemeClr>
+            </a:gs>
+            <a:gs pos="100000">
+              <a:schemeClr val="phClr">
+                <a:lumMod val="105000"/>
+                <a:satMod val="109000"/>
+                <a:tint val="81000"/>
+              </a:schemeClr>
+            </a:gs>
+          </a:gsLst>
+          <a:lin ang="5400000" scaled="0"/>
+        </a:gradFill>
+        <a:gradFill rotWithShape="1">
+          <a:gsLst>
+            <a:gs pos="0">
+              <a:schemeClr val="phClr">
+                <a:satMod val="103000"/>
+                <a:lumMod val="102000"/>
+                <a:tint val="94000"/>
+              </a:schemeClr>
+            </a:gs>
+            <a:gs pos="50000">
+              <a:schemeClr val="phClr">
+                <a:satMod val="110000"/>
+                <a:lumMod val="100000"/>
+                <a:shade val="100000"/>
+              </a:schemeClr>
+            </a:gs>
+            <a:gs pos="100000">
+              <a:schemeClr val="phClr">
+                <a:lumMod val="99000"/>
+                <a:satMod val="120000"/>
+                <a:shade val="78000"/>
+              </a:schemeClr>
+            </a:gs>
+          </a:gsLst>
+          <a:lin ang="5400000" scaled="0"/>
+        </a:gradFill>
+      </a:fillStyleLst>
+      <a:lnStyleLst>
+        <a:ln w="6350" cap="flat" cmpd="sng" algn="ctr">
+          <a:solidFill>
+            <a:schemeClr val="phClr"/>
+          </a:solidFill>
+          <a:prstDash val="solid"/>
+          <a:miter lim="800000"/>
+        </a:ln>
+        <a:ln w="12700" cap="flat" cmpd="sng" algn="ctr">
+          <a:solidFill>
+            <a:schemeClr val="phClr"/>
+          </a:solidFill>
+          <a:prstDash val="solid"/>
+          <a:miter lim="800000"/>
+        </a:ln>
+        <a:ln w="19050" cap="flat" cmpd="sng" algn="ctr">
+          <a:solidFill>
+            <a:schemeClr val="phClr"/>
+          </a:solidFill>
+          <a:prstDash val="solid"/>
+          <a:miter lim="800000"/>
+        </a:ln>
+      </a:lnStyleLst>
+      <a:effectStyleLst>
+        <a:effectStyle>
+          <a:effectLst/>
+        </a:effectStyle>
+        <a:effectStyle>
+          <a:effectLst/>
+        </a:effectStyle>
+        <a:effectStyle>
+          <a:effectLst>
+            <a:outerShdw blurRad="57150" dist="19050" dir="5400000" algn="ctr" rotWithShape="0">
+              <a:srgbClr val="000000">
+                <a:alpha val="63000"/>
+              </a:srgbClr>
+            </a:outerShdw>
+          </a:effectLst>
+        </a:effectStyle>
+      </a:effectStyleLst>
+      <a:bgFillStyleLst>
+        <a:solidFill>
+          <a:schemeClr val="phClr"/>
+        </a:solidFill>
+        <a:solidFill>
+          <a:schemeClr val="phClr">
+            <a:tint val="95000"/>
+            <a:satMod val="170000"/>
+          </a:schemeClr>
+        </a:solidFill>
+        <a:gradFill rotWithShape="1">
+          <a:gsLst>
+            <a:gs pos="0">
+              <a:schemeClr val="phClr">
+                <a:tint val="93000"/>
+                <a:satMod val="150000"/>
+                <a:shade val="98000"/>
+                <a:lumMod val="102000"/>
+              </a:schemeClr>
+            </a:gs>
+            <a:gs pos="50000">
+              <a:schemeClr val="phClr">
+                <a:tint val="98000"/>
+                <a:satMod val="130000"/>
+                <a:shade val="90000"/>
+                <a:lumMod val="103000"/>
+              </a:schemeClr>
+            </a:gs>
+            <a:gs pos="100000">
+              <a:schemeClr val="phClr">
+                <a:shade val="63000"/>
+                <a:satMod val="120000"/>
+              </a:schemeClr>
+            </a:gs>
+          </a:gsLst>
+          <a:lin ang="5400000" scaled="0"/>
+        </a:gradFill>
+      </a:bgFillStyleLst>
+    </a:fmtScheme>
+  </a:themeElements>
+  <a:objectDefaults/>
+  <a:extraClrSchemeLst/>
+  <a:extLst>
+    <a:ext uri="{05A4C25C-085E-4340-85A3-A5531E510DB2}">
+      <thm15:themeFamily xmlns:thm15="http://schemas.microsoft.com/office/thememl/2012/main" name="Office Theme" id="{62F939B6-93AF-4DB8-9C6B-D6C7DFDC589F}" vid="{4A3C46E8-61CC-4603-A589-7422A47A8E4A}"/>
+    </a:ext>
+  </a:extLst>
+</a:theme>
 </file>
</xml_diff>